<commit_message>
media-memory: pricing slides reordered to match original top-to-bottom flow
Co-Authored-By: Claude Fable 5 <noreply@anthropic.com>
Claude-Session: https://claude.ai/code/session_012oaUYezjbRZg4R6ujPtnYc
</commit_message>
<xml_diff>
--- a/media-memory/2026/08/11bf5ee6-c7c9-42de-98d1-555909805943_BEYOND-THE-PRACTICE-full-refreshed.pptx
+++ b/media-memory/2026/08/11bf5ee6-c7c9-42de-98d1-555909805943_BEYOND-THE-PRACTICE-full-refreshed.pptx
@@ -8786,8 +8786,8 @@
         </p:nvSpPr>
         <p:spPr>
           <a:xfrm>
-            <a:off x="6172200" y="1463040"/>
-            <a:ext cx="5468112" cy="4754880"/>
+            <a:off x="548640" y="1188720"/>
+            <a:ext cx="11091672" cy="1920240"/>
           </a:xfrm>
           <a:prstGeom prst="rect">
             <a:avLst/>
@@ -8801,15 +8801,62 @@
           <a:p>
             <a:pPr rtl="1" algn="r" indent="0" marL="0">
               <a:lnSpc>
-                <a:spcPct val="114000"/>
+                <a:spcPct val="112000"/>
+              </a:lnSpc>
+              <a:spcAft>
+                <a:spcPts val="300"/>
+              </a:spcAft>
+              <a:buNone/>
+            </a:pPr>
+            <a:r>
+              <a:rPr lang="he-IL" altLang="en-US" sz="1400" dirty="0">
+                <a:solidFill>
+                  <a:srgbClr val="26221E"/>
+                </a:solidFill>
+                <a:latin typeface="Arial" pitchFamily="34" charset="0"/>
+                <a:ea typeface="Arial" pitchFamily="34" charset="-122"/>
+                <a:cs typeface="Arial" pitchFamily="34" charset="-120"/>
+              </a:rPr>
+              <a:t>מטופלת מבקשת מזרק אחד למילוי השקע</a:t>
+            </a:r>
+            <a:endParaRPr lang="he-IL" sz="1400" dirty="0"/>
+          </a:p>
+          <a:p>
+            <a:pPr rtl="1" algn="r" indent="0" marL="0">
+              <a:lnSpc>
+                <a:spcPct val="112000"/>
+              </a:lnSpc>
+              <a:spcAft>
+                <a:spcPts val="700"/>
+              </a:spcAft>
+              <a:buNone/>
+            </a:pPr>
+            <a:r>
+              <a:rPr lang="he-IL" altLang="en-US" sz="1400" b="1" dirty="0">
+                <a:solidFill>
+                  <a:srgbClr val="26221E"/>
+                </a:solidFill>
+                <a:latin typeface="Arial" pitchFamily="34" charset="0"/>
+                <a:ea typeface="Arial" pitchFamily="34" charset="-122"/>
+                <a:cs typeface="Arial" pitchFamily="34" charset="-120"/>
+              </a:rPr>
+              <a:t>זה הזמן לשנות את השיח – ולהציע פתרון מקיף ואפקטיבי הרבה יותר</a:t>
+            </a:r>
+            <a:endParaRPr lang="he-IL" sz="1400" dirty="0"/>
+          </a:p>
+          <a:p>
+            <a:pPr rtl="1" algn="r" marL="342900" indent="-342900">
+              <a:lnSpc>
+                <a:spcPct val="112000"/>
               </a:lnSpc>
               <a:spcAft>
                 <a:spcPts val="400"/>
               </a:spcAft>
-              <a:buNone/>
-            </a:pPr>
-            <a:r>
-              <a:rPr lang="he-IL" altLang="en-US" sz="1450" dirty="0">
+              <a:buSzPct val="100000"/>
+              <a:buChar char="•"/>
+            </a:pPr>
+            <a:r>
+              <a:rPr lang="he-IL" altLang="en-US" sz="1400" dirty="0">
                 <a:solidFill>
                   <a:srgbClr val="26221E"/>
                 </a:solidFill>
@@ -8817,46 +8864,23 @@
                 <a:ea typeface="Arial" pitchFamily="34" charset="-122"/>
                 <a:cs typeface="Arial" pitchFamily="34" charset="-120"/>
               </a:rPr>
-              <a:t>מטופלת מבקשת מזרק אחד למילוי השקע</a:t>
-            </a:r>
-            <a:endParaRPr lang="he-IL" sz="1450" dirty="0"/>
-          </a:p>
-          <a:p>
-            <a:pPr rtl="1" algn="r" indent="0" marL="0">
-              <a:lnSpc>
-                <a:spcPct val="114000"/>
+              <a:t>שיפור טקסטורת העור – טיפול בקמטוטים ובעור העודף באמצעות סלבוסטר או חומרים ביו-רבאליים</a:t>
+            </a:r>
+            <a:endParaRPr lang="he-IL" sz="1400" dirty="0"/>
+          </a:p>
+          <a:p>
+            <a:pPr rtl="1" algn="r" marL="342900" indent="-342900">
+              <a:lnSpc>
+                <a:spcPct val="112000"/>
               </a:lnSpc>
               <a:spcAft>
-                <a:spcPts val="1000"/>
-              </a:spcAft>
-              <a:buNone/>
-            </a:pPr>
-            <a:r>
-              <a:rPr lang="he-IL" altLang="en-US" sz="1450" b="1" dirty="0">
-                <a:solidFill>
-                  <a:srgbClr val="26221E"/>
-                </a:solidFill>
-                <a:latin typeface="Arial" pitchFamily="34" charset="0"/>
-                <a:ea typeface="Arial" pitchFamily="34" charset="-122"/>
-                <a:cs typeface="Arial" pitchFamily="34" charset="-120"/>
-              </a:rPr>
-              <a:t>זה הזמן לשנות את השיח – ולהציע פתרון מקיף ואפקטיבי הרבה יותר</a:t>
-            </a:r>
-            <a:endParaRPr lang="he-IL" sz="1450" dirty="0"/>
-          </a:p>
-          <a:p>
-            <a:pPr rtl="1" algn="r" marL="342900" indent="-342900">
-              <a:lnSpc>
-                <a:spcPct val="114000"/>
-              </a:lnSpc>
-              <a:spcAft>
-                <a:spcPts val="800"/>
+                <a:spcPts val="400"/>
               </a:spcAft>
               <a:buSzPct val="100000"/>
               <a:buChar char="•"/>
             </a:pPr>
             <a:r>
-              <a:rPr lang="he-IL" altLang="en-US" sz="1450" dirty="0">
+              <a:rPr lang="he-IL" altLang="en-US" sz="1400" dirty="0">
                 <a:solidFill>
                   <a:srgbClr val="26221E"/>
                 </a:solidFill>
@@ -8864,23 +8888,23 @@
                 <a:ea typeface="Arial" pitchFamily="34" charset="-122"/>
                 <a:cs typeface="Arial" pitchFamily="34" charset="-120"/>
               </a:rPr>
-              <a:t>שיפור טקסטורת העור – טיפול בקמטוטים ובעור העודף באמצעות סלבוסטר או חומרים ביו-רבאליים</a:t>
-            </a:r>
-            <a:endParaRPr lang="he-IL" sz="1450" dirty="0"/>
+              <a:t>בוטוקס בצידי העיניים – לשחרור השריר שמושך את האזור כלפי מטה, וליצירת אפקט הרמה טבעי</a:t>
+            </a:r>
+            <a:endParaRPr lang="he-IL" sz="1400" dirty="0"/>
           </a:p>
           <a:p>
             <a:pPr rtl="1" algn="r" marL="342900" indent="-342900">
               <a:lnSpc>
-                <a:spcPct val="114000"/>
+                <a:spcPct val="112000"/>
               </a:lnSpc>
               <a:spcAft>
-                <a:spcPts val="800"/>
+                <a:spcPts val="400"/>
               </a:spcAft>
               <a:buSzPct val="100000"/>
               <a:buChar char="•"/>
             </a:pPr>
             <a:r>
-              <a:rPr lang="he-IL" altLang="en-US" sz="1450" dirty="0">
+              <a:rPr lang="he-IL" altLang="en-US" sz="1400" dirty="0">
                 <a:solidFill>
                   <a:srgbClr val="26221E"/>
                 </a:solidFill>
@@ -8888,23 +8912,20 @@
                 <a:ea typeface="Arial" pitchFamily="34" charset="-122"/>
                 <a:cs typeface="Arial" pitchFamily="34" charset="-120"/>
               </a:rPr>
-              <a:t>בוטוקס בצידי העיניים – לשחרור השריר שמושך את האזור כלפי מטה, וליצירת אפקט הרמה טבעי</a:t>
-            </a:r>
-            <a:endParaRPr lang="he-IL" sz="1450" dirty="0"/>
+              <a:t>מילוי מדויק באמצעות חומצה היאלורונית – לשחזור נפח ואיזון השקע</a:t>
+            </a:r>
+            <a:endParaRPr lang="he-IL" sz="1400" dirty="0"/>
           </a:p>
           <a:p>
             <a:pPr rtl="1" algn="r" marL="342900" indent="-342900">
               <a:lnSpc>
-                <a:spcPct val="114000"/>
-              </a:lnSpc>
-              <a:spcAft>
-                <a:spcPts val="800"/>
-              </a:spcAft>
+                <a:spcPct val="112000"/>
+              </a:lnSpc>
               <a:buSzPct val="100000"/>
               <a:buChar char="•"/>
             </a:pPr>
             <a:r>
-              <a:rPr lang="he-IL" altLang="en-US" sz="1450" dirty="0">
+              <a:rPr lang="he-IL" altLang="en-US" sz="1400" dirty="0">
                 <a:solidFill>
                   <a:srgbClr val="26221E"/>
                 </a:solidFill>
@@ -8912,30 +8933,9 @@
                 <a:ea typeface="Arial" pitchFamily="34" charset="-122"/>
                 <a:cs typeface="Arial" pitchFamily="34" charset="-120"/>
               </a:rPr>
-              <a:t>מילוי מדויק באמצעות חומצה היאלורונית – לשחזור נפח ואיזון השקע</a:t>
-            </a:r>
-            <a:endParaRPr lang="he-IL" sz="1450" dirty="0"/>
-          </a:p>
-          <a:p>
-            <a:pPr rtl="1" algn="r" marL="342900" indent="-342900">
-              <a:lnSpc>
-                <a:spcPct val="114000"/>
-              </a:lnSpc>
-              <a:buSzPct val="100000"/>
-              <a:buChar char="•"/>
-            </a:pPr>
-            <a:r>
-              <a:rPr lang="he-IL" altLang="en-US" sz="1450" dirty="0">
-                <a:solidFill>
-                  <a:srgbClr val="26221E"/>
-                </a:solidFill>
-                <a:latin typeface="Arial" pitchFamily="34" charset="0"/>
-                <a:ea typeface="Arial" pitchFamily="34" charset="-122"/>
-                <a:cs typeface="Arial" pitchFamily="34" charset="-120"/>
-              </a:rPr>
               <a:t>טיפול בכהויות – עם סלבוסטר, אנטיאז' או חומרים מתקדמים נוספים, לפי הצורך האישי</a:t>
             </a:r>
-            <a:endParaRPr lang="he-IL" sz="1450" dirty="0"/>
+            <a:endParaRPr lang="he-IL" sz="1400" dirty="0"/>
           </a:p>
         </p:txBody>
       </p:sp>
@@ -8947,12 +8947,12 @@
         </p:nvSpPr>
         <p:spPr>
           <a:xfrm>
-            <a:off x="548640" y="1463040"/>
-            <a:ext cx="5349240" cy="4800600"/>
+            <a:off x="1371600" y="3291840"/>
+            <a:ext cx="10268712" cy="2880360"/>
           </a:xfrm>
           <a:prstGeom prst="roundRect">
             <a:avLst>
-              <a:gd name="adj" fmla="val 1905"/>
+              <a:gd name="adj" fmla="val 3175"/>
             </a:avLst>
           </a:prstGeom>
           <a:solidFill>
@@ -8976,8 +8976,8 @@
         </p:nvSpPr>
         <p:spPr>
           <a:xfrm>
-            <a:off x="868680" y="1691640"/>
-            <a:ext cx="4709160" cy="411480"/>
+            <a:off x="1691640" y="3474720"/>
+            <a:ext cx="9628632" cy="365760"/>
           </a:xfrm>
           <a:prstGeom prst="rect">
             <a:avLst/>
@@ -8993,7 +8993,7 @@
               <a:buNone/>
             </a:pPr>
             <a:r>
-              <a:rPr lang="he-IL" altLang="en-US" sz="1700" b="1" dirty="0">
+              <a:rPr lang="he-IL" altLang="en-US" sz="1650" b="1" dirty="0">
                 <a:solidFill>
                   <a:srgbClr val="8A6E52"/>
                 </a:solidFill>
@@ -9003,7 +9003,7 @@
               </a:rPr>
               <a:t>מה יוצא לכם מזה</a:t>
             </a:r>
-            <a:endParaRPr lang="he-IL" sz="1700" dirty="0"/>
+            <a:endParaRPr lang="he-IL" sz="1650" dirty="0"/>
           </a:p>
         </p:txBody>
       </p:sp>
@@ -9015,8 +9015,8 @@
         </p:nvSpPr>
         <p:spPr>
           <a:xfrm>
-            <a:off x="868680" y="2194560"/>
-            <a:ext cx="4709160" cy="3931920"/>
+            <a:off x="1691640" y="3886200"/>
+            <a:ext cx="9628632" cy="2148840"/>
           </a:xfrm>
           <a:prstGeom prst="rect">
             <a:avLst/>
@@ -9030,7 +9030,76 @@
           <a:p>
             <a:pPr rtl="1" algn="r" indent="0" marL="0">
               <a:lnSpc>
-                <a:spcPct val="112000"/>
+                <a:spcPct val="110000"/>
+              </a:lnSpc>
+              <a:spcAft>
+                <a:spcPts val="300"/>
+              </a:spcAft>
+              <a:buNone/>
+            </a:pPr>
+            <a:r>
+              <a:rPr lang="he-IL" altLang="en-US" sz="1300" dirty="0">
+                <a:solidFill>
+                  <a:srgbClr val="26221E"/>
+                </a:solidFill>
+                <a:latin typeface="Arial" pitchFamily="34" charset="0"/>
+                <a:ea typeface="Arial" pitchFamily="34" charset="-122"/>
+                <a:cs typeface="Arial" pitchFamily="34" charset="-120"/>
+              </a:rPr>
+              <a:t>במקום למכור מזרק ב-1,500–1,800 ₪ כמו כולם,</a:t>
+            </a:r>
+            <a:endParaRPr lang="he-IL" sz="1300" dirty="0"/>
+          </a:p>
+          <a:p>
+            <a:pPr rtl="1" algn="r" indent="0" marL="0">
+              <a:lnSpc>
+                <a:spcPct val="110000"/>
+              </a:lnSpc>
+              <a:spcAft>
+                <a:spcPts val="300"/>
+              </a:spcAft>
+              <a:buNone/>
+            </a:pPr>
+            <a:r>
+              <a:rPr lang="he-IL" altLang="en-US" sz="1300" dirty="0">
+                <a:solidFill>
+                  <a:srgbClr val="26221E"/>
+                </a:solidFill>
+                <a:latin typeface="Arial" pitchFamily="34" charset="0"/>
+                <a:ea typeface="Arial" pitchFamily="34" charset="-122"/>
+                <a:cs typeface="Arial" pitchFamily="34" charset="-120"/>
+              </a:rPr>
+              <a:t>אתם מציעים טיפול משולב, מדורג, מקצועי ומבדל –</a:t>
+            </a:r>
+            <a:endParaRPr lang="he-IL" sz="1300" dirty="0"/>
+          </a:p>
+          <a:p>
+            <a:pPr rtl="1" algn="r" indent="0" marL="0">
+              <a:lnSpc>
+                <a:spcPct val="110000"/>
+              </a:lnSpc>
+              <a:spcAft>
+                <a:spcPts val="600"/>
+              </a:spcAft>
+              <a:buNone/>
+            </a:pPr>
+            <a:r>
+              <a:rPr lang="he-IL" altLang="en-US" sz="1300" dirty="0">
+                <a:solidFill>
+                  <a:srgbClr val="26221E"/>
+                </a:solidFill>
+                <a:latin typeface="Arial" pitchFamily="34" charset="0"/>
+                <a:ea typeface="Arial" pitchFamily="34" charset="-122"/>
+                <a:cs typeface="Arial" pitchFamily="34" charset="-120"/>
+              </a:rPr>
+              <a:t>עם תמחור מתאים שמייצג את הערך האמיתי של מה שהמטופלת מקבלת</a:t>
+            </a:r>
+            <a:endParaRPr lang="he-IL" sz="1300" dirty="0"/>
+          </a:p>
+          <a:p>
+            <a:pPr rtl="1" algn="r" indent="0" marL="0">
+              <a:lnSpc>
+                <a:spcPct val="110000"/>
               </a:lnSpc>
               <a:spcAft>
                 <a:spcPts val="400"/>
@@ -9038,7 +9107,7 @@
               <a:buNone/>
             </a:pPr>
             <a:r>
-              <a:rPr lang="he-IL" altLang="en-US" sz="1350" dirty="0">
+              <a:rPr lang="he-IL" altLang="en-US" sz="1300" b="1" dirty="0">
                 <a:solidFill>
                   <a:srgbClr val="26221E"/>
                 </a:solidFill>
@@ -9046,92 +9115,23 @@
                 <a:ea typeface="Arial" pitchFamily="34" charset="-122"/>
                 <a:cs typeface="Arial" pitchFamily="34" charset="-120"/>
               </a:rPr>
-              <a:t>במקום למכור מזרק ב-1,500–1,800 ₪ כמו כולם,</a:t>
-            </a:r>
-            <a:endParaRPr lang="he-IL" sz="1350" dirty="0"/>
-          </a:p>
-          <a:p>
-            <a:pPr rtl="1" algn="r" indent="0" marL="0">
-              <a:lnSpc>
-                <a:spcPct val="112000"/>
+              <a:t>כך אתם:</a:t>
+            </a:r>
+            <a:endParaRPr lang="he-IL" sz="1300" dirty="0"/>
+          </a:p>
+          <a:p>
+            <a:pPr rtl="1" algn="r" marL="342900" indent="-342900">
+              <a:lnSpc>
+                <a:spcPct val="110000"/>
               </a:lnSpc>
               <a:spcAft>
-                <a:spcPts val="400"/>
-              </a:spcAft>
-              <a:buNone/>
-            </a:pPr>
-            <a:r>
-              <a:rPr lang="he-IL" altLang="en-US" sz="1350" dirty="0">
-                <a:solidFill>
-                  <a:srgbClr val="26221E"/>
-                </a:solidFill>
-                <a:latin typeface="Arial" pitchFamily="34" charset="0"/>
-                <a:ea typeface="Arial" pitchFamily="34" charset="-122"/>
-                <a:cs typeface="Arial" pitchFamily="34" charset="-120"/>
-              </a:rPr>
-              <a:t>אתם מציעים טיפול משולב, מדורג, מקצועי ומבדל –</a:t>
-            </a:r>
-            <a:endParaRPr lang="he-IL" sz="1350" dirty="0"/>
-          </a:p>
-          <a:p>
-            <a:pPr rtl="1" algn="r" indent="0" marL="0">
-              <a:lnSpc>
-                <a:spcPct val="112000"/>
-              </a:lnSpc>
-              <a:spcAft>
-                <a:spcPts val="1000"/>
-              </a:spcAft>
-              <a:buNone/>
-            </a:pPr>
-            <a:r>
-              <a:rPr lang="he-IL" altLang="en-US" sz="1350" dirty="0">
-                <a:solidFill>
-                  <a:srgbClr val="26221E"/>
-                </a:solidFill>
-                <a:latin typeface="Arial" pitchFamily="34" charset="0"/>
-                <a:ea typeface="Arial" pitchFamily="34" charset="-122"/>
-                <a:cs typeface="Arial" pitchFamily="34" charset="-120"/>
-              </a:rPr>
-              <a:t>עם תמחור מתאים שמייצג את הערך האמיתי של מה שהמטופלת מקבלת</a:t>
-            </a:r>
-            <a:endParaRPr lang="he-IL" sz="1350" dirty="0"/>
-          </a:p>
-          <a:p>
-            <a:pPr rtl="1" algn="r" indent="0" marL="0">
-              <a:lnSpc>
-                <a:spcPct val="112000"/>
-              </a:lnSpc>
-              <a:spcAft>
-                <a:spcPts val="600"/>
-              </a:spcAft>
-              <a:buNone/>
-            </a:pPr>
-            <a:r>
-              <a:rPr lang="he-IL" altLang="en-US" sz="1350" b="1" dirty="0">
-                <a:solidFill>
-                  <a:srgbClr val="26221E"/>
-                </a:solidFill>
-                <a:latin typeface="Arial" pitchFamily="34" charset="0"/>
-                <a:ea typeface="Arial" pitchFamily="34" charset="-122"/>
-                <a:cs typeface="Arial" pitchFamily="34" charset="-120"/>
-              </a:rPr>
-              <a:t>כך אתם:</a:t>
-            </a:r>
-            <a:endParaRPr lang="he-IL" sz="1350" dirty="0"/>
-          </a:p>
-          <a:p>
-            <a:pPr rtl="1" algn="r" marL="342900" indent="-342900">
-              <a:lnSpc>
-                <a:spcPct val="112000"/>
-              </a:lnSpc>
-              <a:spcAft>
-                <a:spcPts val="600"/>
+                <a:spcPts val="300"/>
               </a:spcAft>
               <a:buSzPct val="100000"/>
               <a:buChar char="•"/>
             </a:pPr>
             <a:r>
-              <a:rPr lang="he-IL" altLang="en-US" sz="1350" dirty="0">
+              <a:rPr lang="he-IL" altLang="en-US" sz="1300" dirty="0">
                 <a:solidFill>
                   <a:srgbClr val="26221E"/>
                 </a:solidFill>
@@ -9141,21 +9141,21 @@
               </a:rPr>
               <a:t>יוצאים מהשיח של “מחיר למזרק”</a:t>
             </a:r>
-            <a:endParaRPr lang="he-IL" sz="1350" dirty="0"/>
+            <a:endParaRPr lang="he-IL" sz="1300" dirty="0"/>
           </a:p>
           <a:p>
             <a:pPr rtl="1" algn="r" marL="342900" indent="-342900">
               <a:lnSpc>
-                <a:spcPct val="112000"/>
+                <a:spcPct val="110000"/>
               </a:lnSpc>
               <a:spcAft>
-                <a:spcPts val="600"/>
+                <a:spcPts val="300"/>
               </a:spcAft>
               <a:buSzPct val="100000"/>
               <a:buChar char="•"/>
             </a:pPr>
             <a:r>
-              <a:rPr lang="he-IL" altLang="en-US" sz="1350" dirty="0">
+              <a:rPr lang="he-IL" altLang="en-US" sz="1300" dirty="0">
                 <a:solidFill>
                   <a:srgbClr val="26221E"/>
                 </a:solidFill>
@@ -9165,21 +9165,21 @@
               </a:rPr>
               <a:t>ממקסמים את תוצאות הטיפול</a:t>
             </a:r>
-            <a:endParaRPr lang="he-IL" sz="1350" dirty="0"/>
+            <a:endParaRPr lang="he-IL" sz="1300" dirty="0"/>
           </a:p>
           <a:p>
             <a:pPr rtl="1" algn="r" marL="342900" indent="-342900">
               <a:lnSpc>
-                <a:spcPct val="112000"/>
+                <a:spcPct val="110000"/>
               </a:lnSpc>
               <a:spcAft>
-                <a:spcPts val="600"/>
+                <a:spcPts val="300"/>
               </a:spcAft>
               <a:buSzPct val="100000"/>
               <a:buChar char="•"/>
             </a:pPr>
             <a:r>
-              <a:rPr lang="he-IL" altLang="en-US" sz="1350" dirty="0">
+              <a:rPr lang="he-IL" altLang="en-US" sz="1300" dirty="0">
                 <a:solidFill>
                   <a:srgbClr val="26221E"/>
                 </a:solidFill>
@@ -9189,18 +9189,18 @@
               </a:rPr>
               <a:t>מייצרים תהליך טיפולי מתמשך שמעמיק את הקשר עם המטופלת</a:t>
             </a:r>
-            <a:endParaRPr lang="he-IL" sz="1350" dirty="0"/>
+            <a:endParaRPr lang="he-IL" sz="1300" dirty="0"/>
           </a:p>
           <a:p>
             <a:pPr rtl="1" algn="r" marL="342900" indent="-342900">
               <a:lnSpc>
-                <a:spcPct val="112000"/>
+                <a:spcPct val="110000"/>
               </a:lnSpc>
               <a:buSzPct val="100000"/>
               <a:buChar char="•"/>
             </a:pPr>
             <a:r>
-              <a:rPr lang="he-IL" altLang="en-US" sz="1350" dirty="0">
+              <a:rPr lang="he-IL" altLang="en-US" sz="1300" dirty="0">
                 <a:solidFill>
                   <a:srgbClr val="26221E"/>
                 </a:solidFill>
@@ -9210,7 +9210,7 @@
               </a:rPr>
               <a:t>ומבדלים את עצמכם כאנשי מקצוע שנותנים מענה שלם – לא פתרון נקודתי</a:t>
             </a:r>
-            <a:endParaRPr lang="he-IL" sz="1350" dirty="0"/>
+            <a:endParaRPr lang="he-IL" sz="1300" dirty="0"/>
           </a:p>
         </p:txBody>
       </p:sp>
@@ -9418,12 +9418,12 @@
         </p:nvSpPr>
         <p:spPr>
           <a:xfrm>
-            <a:off x="6263640" y="2057400"/>
-            <a:ext cx="5376672" cy="3063240"/>
+            <a:off x="548640" y="1874520"/>
+            <a:ext cx="11091672" cy="1874520"/>
           </a:xfrm>
           <a:prstGeom prst="roundRect">
             <a:avLst>
-              <a:gd name="adj" fmla="val 2985"/>
+              <a:gd name="adj" fmla="val 4878"/>
             </a:avLst>
           </a:prstGeom>
           <a:solidFill>
@@ -9447,8 +9447,8 @@
         </p:nvSpPr>
         <p:spPr>
           <a:xfrm>
-            <a:off x="6583680" y="2331720"/>
-            <a:ext cx="4754880" cy="457200"/>
+            <a:off x="868680" y="2103120"/>
+            <a:ext cx="10451592" cy="1463040"/>
           </a:xfrm>
           <a:prstGeom prst="rect">
             <a:avLst/>
@@ -9461,6 +9461,12 @@
           <a:lstStyle/>
           <a:p>
             <a:pPr rtl="1" algn="r" indent="0" marL="0">
+              <a:lnSpc>
+                <a:spcPct val="115000"/>
+              </a:lnSpc>
+              <a:spcAft>
+                <a:spcPts val="800"/>
+              </a:spcAft>
               <a:buNone/>
             </a:pPr>
             <a:r>
@@ -9472,130 +9478,69 @@
                 <a:ea typeface="Arial" pitchFamily="34" charset="-122"/>
                 <a:cs typeface="Arial" pitchFamily="34" charset="-120"/>
               </a:rPr>
-              <a:t>מזרק למילוי</a:t>
-            </a:r>
-            <a:endParaRPr lang="he-IL" sz="1800" dirty="0"/>
+              <a:t>מזרק למילוי:</a:t>
+            </a:r>
+            <a:endParaRPr lang="he-IL" sz="1550" dirty="0"/>
+          </a:p>
+          <a:p>
+            <a:pPr rtl="1" algn="r" indent="0" marL="0">
+              <a:lnSpc>
+                <a:spcPct val="115000"/>
+              </a:lnSpc>
+              <a:spcAft>
+                <a:spcPts val="600"/>
+              </a:spcAft>
+              <a:buNone/>
+            </a:pPr>
+            <a:r>
+              <a:rPr lang="he-IL" altLang="en-US" sz="1550" dirty="0">
+                <a:solidFill>
+                  <a:srgbClr val="26221E"/>
+                </a:solidFill>
+                <a:latin typeface="Arial" pitchFamily="34" charset="0"/>
+                <a:ea typeface="Arial" pitchFamily="34" charset="-122"/>
+                <a:cs typeface="Arial" pitchFamily="34" charset="-120"/>
+              </a:rPr>
+              <a:t>ברכישה של 30 מזרקים ומעלה, מחיר מבצע עומד על כ־330 ש”ח + מע”מ</a:t>
+            </a:r>
+            <a:endParaRPr lang="he-IL" sz="1550" dirty="0"/>
+          </a:p>
+          <a:p>
+            <a:pPr rtl="1" algn="r" indent="0" marL="0">
+              <a:lnSpc>
+                <a:spcPct val="115000"/>
+              </a:lnSpc>
+              <a:buNone/>
+            </a:pPr>
+            <a:r>
+              <a:rPr lang="he-IL" altLang="en-US" sz="1550" b="1" dirty="0">
+                <a:solidFill>
+                  <a:srgbClr val="8A6E52"/>
+                </a:solidFill>
+                <a:latin typeface="Arial" pitchFamily="34" charset="0"/>
+                <a:ea typeface="Arial" pitchFamily="34" charset="-122"/>
+                <a:cs typeface="Arial" pitchFamily="34" charset="-120"/>
+              </a:rPr>
+              <a:t>לבוגרי הקורס – המחיר המוזל הוא 250 ש”ח</a:t>
+            </a:r>
+            <a:endParaRPr lang="he-IL" sz="1550" dirty="0"/>
           </a:p>
         </p:txBody>
       </p:sp>
       <p:sp>
         <p:nvSpPr>
-          <p:cNvPr id="9" name="Text 6"/>
+          <p:cNvPr id="9" name="Shape 6"/>
           <p:cNvSpPr/>
           <p:nvPr/>
         </p:nvSpPr>
         <p:spPr>
           <a:xfrm>
-            <a:off x="6583680" y="2926080"/>
-            <a:ext cx="4754880" cy="685800"/>
-          </a:xfrm>
-          <a:prstGeom prst="rect">
-            <a:avLst/>
-          </a:prstGeom>
-          <a:noFill/>
-          <a:ln/>
-        </p:spPr>
-        <p:txBody>
-          <a:bodyPr wrap="square" lIns="0" tIns="0" rIns="0" bIns="0" rtlCol="0" anchor="t"/>
-          <a:lstStyle/>
-          <a:p>
-            <a:pPr rtl="1" algn="r" indent="0" marL="0">
-              <a:buNone/>
-            </a:pPr>
-            <a:r>
-              <a:rPr lang="he-IL" altLang="en-US" sz="3200" b="1" dirty="0">
-                <a:solidFill>
-                  <a:srgbClr val="8A6E52"/>
-                </a:solidFill>
-                <a:latin typeface="Arial" pitchFamily="34" charset="0"/>
-                <a:ea typeface="Arial" pitchFamily="34" charset="-122"/>
-                <a:cs typeface="Arial" pitchFamily="34" charset="-120"/>
-              </a:rPr>
-              <a:t>330 ש”ח + מע”מ</a:t>
-            </a:r>
-            <a:endParaRPr lang="he-IL" sz="3200" dirty="0"/>
-          </a:p>
-        </p:txBody>
-      </p:sp>
-      <p:sp>
-        <p:nvSpPr>
-          <p:cNvPr id="10" name="Text 7"/>
-          <p:cNvSpPr/>
-          <p:nvPr/>
-        </p:nvSpPr>
-        <p:spPr>
-          <a:xfrm>
-            <a:off x="6583680" y="3794760"/>
-            <a:ext cx="4754880" cy="1143000"/>
-          </a:xfrm>
-          <a:prstGeom prst="rect">
-            <a:avLst/>
-          </a:prstGeom>
-          <a:noFill/>
-          <a:ln/>
-        </p:spPr>
-        <p:txBody>
-          <a:bodyPr wrap="square" lIns="0" tIns="0" rIns="0" bIns="0" rtlCol="0" anchor="t"/>
-          <a:lstStyle/>
-          <a:p>
-            <a:pPr rtl="1" algn="r" indent="0" marL="0">
-              <a:lnSpc>
-                <a:spcPct val="115000"/>
-              </a:lnSpc>
-              <a:spcAft>
-                <a:spcPts val="1000"/>
-              </a:spcAft>
-              <a:buNone/>
-            </a:pPr>
-            <a:r>
-              <a:rPr lang="he-IL" altLang="en-US" sz="1450" dirty="0">
-                <a:solidFill>
-                  <a:srgbClr val="26221E"/>
-                </a:solidFill>
-                <a:latin typeface="Arial" pitchFamily="34" charset="0"/>
-                <a:ea typeface="Arial" pitchFamily="34" charset="-122"/>
-                <a:cs typeface="Arial" pitchFamily="34" charset="-120"/>
-              </a:rPr>
-              <a:t>ברכישה של 30 מזרקים ומעלה, מחיר מבצע עומד על כ־330 ש”ח + מע”מ</a:t>
-            </a:r>
-            <a:endParaRPr lang="he-IL" sz="1450" dirty="0"/>
-          </a:p>
-          <a:p>
-            <a:pPr rtl="1" algn="r" indent="0" marL="0">
-              <a:lnSpc>
-                <a:spcPct val="115000"/>
-              </a:lnSpc>
-              <a:buNone/>
-            </a:pPr>
-            <a:r>
-              <a:rPr lang="he-IL" altLang="en-US" sz="1450" b="1" dirty="0">
-                <a:solidFill>
-                  <a:srgbClr val="26221E"/>
-                </a:solidFill>
-                <a:latin typeface="Arial" pitchFamily="34" charset="0"/>
-                <a:ea typeface="Arial" pitchFamily="34" charset="-122"/>
-                <a:cs typeface="Arial" pitchFamily="34" charset="-120"/>
-              </a:rPr>
-              <a:t>לבוגרי הקורס – המחיר המוזל הוא 250 ש”ח</a:t>
-            </a:r>
-            <a:endParaRPr lang="he-IL" sz="1450" dirty="0"/>
-          </a:p>
-        </p:txBody>
-      </p:sp>
-      <p:sp>
-        <p:nvSpPr>
-          <p:cNvPr id="11" name="Shape 8"/>
-          <p:cNvSpPr/>
-          <p:nvPr/>
-        </p:nvSpPr>
-        <p:spPr>
-          <a:xfrm>
-            <a:off x="548640" y="2057400"/>
-            <a:ext cx="5349240" cy="3063240"/>
+            <a:off x="548640" y="3977640"/>
+            <a:ext cx="11091672" cy="1874520"/>
           </a:xfrm>
           <a:prstGeom prst="roundRect">
             <a:avLst>
-              <a:gd name="adj" fmla="val 2985"/>
+              <a:gd name="adj" fmla="val 4878"/>
             </a:avLst>
           </a:prstGeom>
           <a:solidFill>
@@ -9613,14 +9558,14 @@
       </p:sp>
       <p:sp>
         <p:nvSpPr>
-          <p:cNvPr id="12" name="Text 9"/>
+          <p:cNvPr id="10" name="Text 7"/>
           <p:cNvSpPr/>
           <p:nvPr/>
         </p:nvSpPr>
         <p:spPr>
           <a:xfrm>
-            <a:off x="868680" y="2331720"/>
-            <a:ext cx="4709160" cy="457200"/>
+            <a:off x="868680" y="4206240"/>
+            <a:ext cx="10451592" cy="1463040"/>
           </a:xfrm>
           <a:prstGeom prst="rect">
             <a:avLst/>
@@ -9633,6 +9578,12 @@
           <a:lstStyle/>
           <a:p>
             <a:pPr rtl="1" algn="r" indent="0" marL="0">
+              <a:lnSpc>
+                <a:spcPct val="115000"/>
+              </a:lnSpc>
+              <a:spcAft>
+                <a:spcPts val="800"/>
+              </a:spcAft>
               <a:buNone/>
             </a:pPr>
             <a:r>
@@ -9646,36 +9597,40 @@
               </a:rPr>
               <a:t>בקבוקון סלבוסטר</a:t>
             </a:r>
-            <a:endParaRPr lang="he-IL" sz="1800" dirty="0"/>
-          </a:p>
-        </p:txBody>
-      </p:sp>
-      <p:sp>
-        <p:nvSpPr>
-          <p:cNvPr id="13" name="Text 10"/>
-          <p:cNvSpPr/>
-          <p:nvPr/>
-        </p:nvSpPr>
-        <p:spPr>
-          <a:xfrm>
-            <a:off x="868680" y="2926080"/>
-            <a:ext cx="4709160" cy="685800"/>
-          </a:xfrm>
-          <a:prstGeom prst="rect">
-            <a:avLst/>
-          </a:prstGeom>
-          <a:noFill/>
-          <a:ln/>
-        </p:spPr>
-        <p:txBody>
-          <a:bodyPr wrap="square" lIns="0" tIns="0" rIns="0" bIns="0" rtlCol="0" anchor="t"/>
-          <a:lstStyle/>
+            <a:endParaRPr lang="he-IL" sz="1550" dirty="0"/>
+          </a:p>
           <a:p>
             <a:pPr rtl="1" algn="r" indent="0" marL="0">
-              <a:buNone/>
-            </a:pPr>
-            <a:r>
-              <a:rPr lang="he-IL" altLang="en-US" sz="3200" b="1" dirty="0">
+              <a:lnSpc>
+                <a:spcPct val="115000"/>
+              </a:lnSpc>
+              <a:spcAft>
+                <a:spcPts val="600"/>
+              </a:spcAft>
+              <a:buNone/>
+            </a:pPr>
+            <a:r>
+              <a:rPr lang="he-IL" altLang="en-US" sz="1550" dirty="0">
+                <a:solidFill>
+                  <a:srgbClr val="26221E"/>
+                </a:solidFill>
+                <a:latin typeface="Arial" pitchFamily="34" charset="0"/>
+                <a:ea typeface="Arial" pitchFamily="34" charset="-122"/>
+                <a:cs typeface="Arial" pitchFamily="34" charset="-120"/>
+              </a:rPr>
+              <a:t>נמכר לרוב בכ־250 ש”ח + מע”מ לרופא (במבצע)</a:t>
+            </a:r>
+            <a:endParaRPr lang="he-IL" sz="1550" dirty="0"/>
+          </a:p>
+          <a:p>
+            <a:pPr rtl="1" algn="r" indent="0" marL="0">
+              <a:lnSpc>
+                <a:spcPct val="115000"/>
+              </a:lnSpc>
+              <a:buNone/>
+            </a:pPr>
+            <a:r>
+              <a:rPr lang="he-IL" altLang="en-US" sz="1550" b="1" dirty="0">
                 <a:solidFill>
                   <a:srgbClr val="8A6E52"/>
                 </a:solidFill>
@@ -9683,74 +9638,9 @@
                 <a:ea typeface="Arial" pitchFamily="34" charset="-122"/>
                 <a:cs typeface="Arial" pitchFamily="34" charset="-120"/>
               </a:rPr>
-              <a:t>250 ש”ח + מע”מ</a:t>
-            </a:r>
-            <a:endParaRPr lang="he-IL" sz="3200" dirty="0"/>
-          </a:p>
-        </p:txBody>
-      </p:sp>
-      <p:sp>
-        <p:nvSpPr>
-          <p:cNvPr id="14" name="Text 11"/>
-          <p:cNvSpPr/>
-          <p:nvPr/>
-        </p:nvSpPr>
-        <p:spPr>
-          <a:xfrm>
-            <a:off x="868680" y="3794760"/>
-            <a:ext cx="4709160" cy="1143000"/>
-          </a:xfrm>
-          <a:prstGeom prst="rect">
-            <a:avLst/>
-          </a:prstGeom>
-          <a:noFill/>
-          <a:ln/>
-        </p:spPr>
-        <p:txBody>
-          <a:bodyPr wrap="square" lIns="0" tIns="0" rIns="0" bIns="0" rtlCol="0" anchor="t"/>
-          <a:lstStyle/>
-          <a:p>
-            <a:pPr rtl="1" algn="r" indent="0" marL="0">
-              <a:lnSpc>
-                <a:spcPct val="115000"/>
-              </a:lnSpc>
-              <a:spcAft>
-                <a:spcPts val="1000"/>
-              </a:spcAft>
-              <a:buNone/>
-            </a:pPr>
-            <a:r>
-              <a:rPr lang="he-IL" altLang="en-US" sz="1450" dirty="0">
-                <a:solidFill>
-                  <a:srgbClr val="26221E"/>
-                </a:solidFill>
-                <a:latin typeface="Arial" pitchFamily="34" charset="0"/>
-                <a:ea typeface="Arial" pitchFamily="34" charset="-122"/>
-                <a:cs typeface="Arial" pitchFamily="34" charset="-120"/>
-              </a:rPr>
-              <a:t>נמכר לרוב בכ־250 ש”ח + מע”מ לרופא (במבצע)</a:t>
-            </a:r>
-            <a:endParaRPr lang="he-IL" sz="1450" dirty="0"/>
-          </a:p>
-          <a:p>
-            <a:pPr rtl="1" algn="r" indent="0" marL="0">
-              <a:lnSpc>
-                <a:spcPct val="115000"/>
-              </a:lnSpc>
-              <a:buNone/>
-            </a:pPr>
-            <a:r>
-              <a:rPr lang="he-IL" altLang="en-US" sz="1450" b="1" dirty="0">
-                <a:solidFill>
-                  <a:srgbClr val="26221E"/>
-                </a:solidFill>
-                <a:latin typeface="Arial" pitchFamily="34" charset="0"/>
-                <a:ea typeface="Arial" pitchFamily="34" charset="-122"/>
-                <a:cs typeface="Arial" pitchFamily="34" charset="-120"/>
-              </a:rPr>
               <a:t>ולבוגרי הקורס – המחיר המוזל הוא 180 ש”ח</a:t>
             </a:r>
-            <a:endParaRPr lang="he-IL" sz="1450" dirty="0"/>
+            <a:endParaRPr lang="he-IL" sz="1550" dirty="0"/>
           </a:p>
         </p:txBody>
       </p:sp>
@@ -9878,7 +9768,7 @@
         <p:spPr>
           <a:xfrm>
             <a:off x="1097280" y="347472"/>
-            <a:ext cx="10543032" cy="868680"/>
+            <a:ext cx="10543032" cy="548640"/>
           </a:xfrm>
           <a:prstGeom prst="rect">
             <a:avLst/>
@@ -9894,7 +9784,7 @@
               <a:buNone/>
             </a:pPr>
             <a:r>
-              <a:rPr lang="he-IL" altLang="en-US" sz="2600" b="1" dirty="0">
+              <a:rPr lang="he-IL" altLang="en-US" sz="2200" b="1" dirty="0">
                 <a:solidFill>
                   <a:srgbClr val="26221E"/>
                 </a:solidFill>
@@ -9902,26 +9792,156 @@
                 <a:ea typeface="Arial" pitchFamily="34" charset="-122"/>
                 <a:cs typeface="Arial" pitchFamily="34" charset="-120"/>
               </a:rPr>
-              <a:t>עלויות נלוות לטיפול</a:t>
-            </a:r>
-            <a:endParaRPr lang="he-IL" sz="2600" dirty="0"/>
+              <a:t>עלות המקום בו מתקיים הטיפול:</a:t>
+            </a:r>
+            <a:endParaRPr lang="he-IL" sz="2200" dirty="0"/>
           </a:p>
         </p:txBody>
       </p:sp>
       <p:sp>
         <p:nvSpPr>
-          <p:cNvPr id="6" name="Shape 3"/>
+          <p:cNvPr id="6" name="Text 3"/>
           <p:cNvSpPr/>
           <p:nvPr/>
         </p:nvSpPr>
         <p:spPr>
           <a:xfrm>
-            <a:off x="6263640" y="1417320"/>
-            <a:ext cx="5376672" cy="2286000"/>
+            <a:off x="548640" y="1005840"/>
+            <a:ext cx="11091672" cy="640080"/>
+          </a:xfrm>
+          <a:prstGeom prst="rect">
+            <a:avLst/>
+          </a:prstGeom>
+          <a:noFill/>
+          <a:ln/>
+        </p:spPr>
+        <p:txBody>
+          <a:bodyPr wrap="square" lIns="0" tIns="0" rIns="0" bIns="0" rtlCol="0" anchor="t"/>
+          <a:lstStyle/>
+          <a:p>
+            <a:pPr rtl="1" algn="r" indent="0" marL="0">
+              <a:lnSpc>
+                <a:spcPct val="115000"/>
+              </a:lnSpc>
+              <a:buNone/>
+            </a:pPr>
+            <a:r>
+              <a:rPr lang="he-IL" altLang="en-US" sz="1550" dirty="0">
+                <a:solidFill>
+                  <a:srgbClr val="26221E"/>
+                </a:solidFill>
+                <a:latin typeface="Arial" pitchFamily="34" charset="0"/>
+                <a:ea typeface="Arial" pitchFamily="34" charset="-122"/>
+                <a:cs typeface="Arial" pitchFamily="34" charset="-120"/>
+              </a:rPr>
+              <a:t>יש לחשב לפי חלוקת עלות שכירות, ארנונה, חשמל, שכר עובדים וכדומה – לפי מספר ימי העבודה בפועל</a:t>
+            </a:r>
+            <a:endParaRPr lang="he-IL" sz="1550" dirty="0"/>
+          </a:p>
+        </p:txBody>
+      </p:sp>
+      <p:sp>
+        <p:nvSpPr>
+          <p:cNvPr id="7" name="Text 4"/>
+          <p:cNvSpPr/>
+          <p:nvPr/>
+        </p:nvSpPr>
+        <p:spPr>
+          <a:xfrm>
+            <a:off x="548640" y="1828800"/>
+            <a:ext cx="11091672" cy="1371600"/>
+          </a:xfrm>
+          <a:prstGeom prst="rect">
+            <a:avLst/>
+          </a:prstGeom>
+          <a:noFill/>
+          <a:ln/>
+        </p:spPr>
+        <p:txBody>
+          <a:bodyPr wrap="square" lIns="0" tIns="0" rIns="0" bIns="0" rtlCol="0" anchor="t"/>
+          <a:lstStyle/>
+          <a:p>
+            <a:pPr rtl="1" algn="r" indent="0" marL="0">
+              <a:lnSpc>
+                <a:spcPct val="115000"/>
+              </a:lnSpc>
+              <a:spcAft>
+                <a:spcPts val="600"/>
+              </a:spcAft>
+              <a:buNone/>
+            </a:pPr>
+            <a:r>
+              <a:rPr lang="he-IL" altLang="en-US" sz="1700" b="1" dirty="0">
+                <a:solidFill>
+                  <a:srgbClr val="26221E"/>
+                </a:solidFill>
+                <a:latin typeface="Arial" pitchFamily="34" charset="0"/>
+                <a:ea typeface="Arial" pitchFamily="34" charset="-122"/>
+                <a:cs typeface="Arial" pitchFamily="34" charset="-120"/>
+              </a:rPr>
+              <a:t>ציוד מתכלה:</a:t>
+            </a:r>
+            <a:endParaRPr lang="he-IL" sz="1550" dirty="0"/>
+          </a:p>
+          <a:p>
+            <a:pPr rtl="1" algn="r" indent="0" marL="0">
+              <a:lnSpc>
+                <a:spcPct val="115000"/>
+              </a:lnSpc>
+              <a:spcAft>
+                <a:spcPts val="400"/>
+              </a:spcAft>
+              <a:buNone/>
+            </a:pPr>
+            <a:r>
+              <a:rPr lang="he-IL" altLang="en-US" sz="1550" dirty="0">
+                <a:solidFill>
+                  <a:srgbClr val="26221E"/>
+                </a:solidFill>
+                <a:latin typeface="Arial" pitchFamily="34" charset="0"/>
+                <a:ea typeface="Arial" pitchFamily="34" charset="-122"/>
+                <a:cs typeface="Arial" pitchFamily="34" charset="-120"/>
+              </a:rPr>
+              <a:t>גזות, אלכוהול, קנולות וכו'</a:t>
+            </a:r>
+            <a:endParaRPr lang="he-IL" sz="1550" dirty="0"/>
+          </a:p>
+          <a:p>
+            <a:pPr rtl="1" algn="r" indent="0" marL="0">
+              <a:lnSpc>
+                <a:spcPct val="115000"/>
+              </a:lnSpc>
+              <a:buNone/>
+            </a:pPr>
+            <a:r>
+              <a:rPr lang="he-IL" altLang="en-US" sz="1550" b="1" dirty="0">
+                <a:solidFill>
+                  <a:srgbClr val="8A6E52"/>
+                </a:solidFill>
+                <a:latin typeface="Arial" pitchFamily="34" charset="0"/>
+                <a:ea typeface="Arial" pitchFamily="34" charset="-122"/>
+                <a:cs typeface="Arial" pitchFamily="34" charset="-120"/>
+              </a:rPr>
+              <a:t>לא עולים יותר מ־50 ש”ח לטיפול</a:t>
+            </a:r>
+            <a:endParaRPr lang="he-IL" sz="1550" dirty="0"/>
+          </a:p>
+        </p:txBody>
+      </p:sp>
+      <p:sp>
+        <p:nvSpPr>
+          <p:cNvPr id="8" name="Shape 5"/>
+          <p:cNvSpPr/>
+          <p:nvPr/>
+        </p:nvSpPr>
+        <p:spPr>
+          <a:xfrm>
+            <a:off x="548640" y="3520440"/>
+            <a:ext cx="11091672" cy="2331720"/>
           </a:xfrm>
           <a:prstGeom prst="roundRect">
             <a:avLst>
-              <a:gd name="adj" fmla="val 4000"/>
+              <a:gd name="adj" fmla="val 3922"/>
             </a:avLst>
           </a:prstGeom>
           <a:solidFill>
@@ -9939,14 +9959,14 @@
       </p:sp>
       <p:sp>
         <p:nvSpPr>
-          <p:cNvPr id="7" name="Text 4"/>
+          <p:cNvPr id="9" name="Text 6"/>
           <p:cNvSpPr/>
           <p:nvPr/>
         </p:nvSpPr>
         <p:spPr>
           <a:xfrm>
-            <a:off x="6583680" y="1645920"/>
-            <a:ext cx="4754880" cy="411480"/>
+            <a:off x="868680" y="3749040"/>
+            <a:ext cx="10451592" cy="457200"/>
           </a:xfrm>
           <a:prstGeom prst="rect">
             <a:avLst/>
@@ -9962,90 +9982,19 @@
               <a:buNone/>
             </a:pPr>
             <a:r>
-              <a:rPr lang="he-IL" altLang="en-US" sz="1600" b="1" dirty="0">
-                <a:solidFill>
-                  <a:srgbClr val="8A6E52"/>
-                </a:solidFill>
-                <a:latin typeface="Arial" pitchFamily="34" charset="0"/>
-                <a:ea typeface="Arial" pitchFamily="34" charset="-122"/>
-                <a:cs typeface="Arial" pitchFamily="34" charset="-120"/>
-              </a:rPr>
-              <a:t>עלות המקום בו מתקיים הטיפול:</a:t>
-            </a:r>
-            <a:endParaRPr lang="he-IL" sz="1600" dirty="0"/>
+              <a:rPr lang="he-IL" altLang="en-US" sz="1800" b="1" dirty="0">
+                <a:solidFill>
+                  <a:srgbClr val="26221E"/>
+                </a:solidFill>
+                <a:latin typeface="Arial" pitchFamily="34" charset="0"/>
+                <a:ea typeface="Arial" pitchFamily="34" charset="-122"/>
+                <a:cs typeface="Arial" pitchFamily="34" charset="-120"/>
+              </a:rPr>
+              <a:t>חישוב עלות חומרית – דוגמה לטיפול הוליסטי בשקעי עיניים</a:t>
+            </a:r>
+            <a:endParaRPr lang="he-IL" sz="1800" dirty="0"/>
           </a:p>
         </p:txBody>
-      </p:sp>
-      <p:sp>
-        <p:nvSpPr>
-          <p:cNvPr id="8" name="Text 5"/>
-          <p:cNvSpPr/>
-          <p:nvPr/>
-        </p:nvSpPr>
-        <p:spPr>
-          <a:xfrm>
-            <a:off x="6583680" y="2148840"/>
-            <a:ext cx="4754880" cy="1371600"/>
-          </a:xfrm>
-          <a:prstGeom prst="rect">
-            <a:avLst/>
-          </a:prstGeom>
-          <a:noFill/>
-          <a:ln/>
-        </p:spPr>
-        <p:txBody>
-          <a:bodyPr wrap="square" lIns="0" tIns="0" rIns="0" bIns="0" rtlCol="0" anchor="t"/>
-          <a:lstStyle/>
-          <a:p>
-            <a:pPr rtl="1" algn="r" indent="0" marL="0">
-              <a:lnSpc>
-                <a:spcPct val="115000"/>
-              </a:lnSpc>
-              <a:buNone/>
-            </a:pPr>
-            <a:r>
-              <a:rPr lang="he-IL" altLang="en-US" sz="1450" dirty="0">
-                <a:solidFill>
-                  <a:srgbClr val="26221E"/>
-                </a:solidFill>
-                <a:latin typeface="Arial" pitchFamily="34" charset="0"/>
-                <a:ea typeface="Arial" pitchFamily="34" charset="-122"/>
-                <a:cs typeface="Arial" pitchFamily="34" charset="-120"/>
-              </a:rPr>
-              <a:t>יש לחשב לפי חלוקת עלות שכירות, ארנונה, חשמל, שכר עובדים וכדומה – לפי מספר ימי העבודה בפועל</a:t>
-            </a:r>
-            <a:endParaRPr lang="he-IL" sz="1450" dirty="0"/>
-          </a:p>
-        </p:txBody>
-      </p:sp>
-      <p:sp>
-        <p:nvSpPr>
-          <p:cNvPr id="9" name="Shape 6"/>
-          <p:cNvSpPr/>
-          <p:nvPr/>
-        </p:nvSpPr>
-        <p:spPr>
-          <a:xfrm>
-            <a:off x="548640" y="1417320"/>
-            <a:ext cx="5349240" cy="2286000"/>
-          </a:xfrm>
-          <a:prstGeom prst="roundRect">
-            <a:avLst>
-              <a:gd name="adj" fmla="val 4000"/>
-            </a:avLst>
-          </a:prstGeom>
-          <a:solidFill>
-            <a:srgbClr val="F3EFE9"/>
-          </a:solidFill>
-          <a:ln/>
-          <a:effectLst>
-            <a:outerShdw sx="100000" sy="100000" kx="0" ky="0" algn="bl" rotWithShape="0" blurRad="88900" dist="25400" dir="5400000">
-              <a:srgbClr val="3B342C">
-                <a:alpha val="18000"/>
-              </a:srgbClr>
-            </a:outerShdw>
-          </a:effectLst>
-        </p:spPr>
       </p:sp>
       <p:sp>
         <p:nvSpPr>
@@ -10055,151 +10004,8 @@
         </p:nvSpPr>
         <p:spPr>
           <a:xfrm>
-            <a:off x="868680" y="1645920"/>
-            <a:ext cx="4709160" cy="411480"/>
-          </a:xfrm>
-          <a:prstGeom prst="rect">
-            <a:avLst/>
-          </a:prstGeom>
-          <a:noFill/>
-          <a:ln/>
-        </p:spPr>
-        <p:txBody>
-          <a:bodyPr wrap="square" lIns="0" tIns="0" rIns="0" bIns="0" rtlCol="0" anchor="t"/>
-          <a:lstStyle/>
-          <a:p>
-            <a:pPr rtl="1" algn="r" indent="0" marL="0">
-              <a:buNone/>
-            </a:pPr>
-            <a:r>
-              <a:rPr lang="he-IL" altLang="en-US" sz="1600" b="1" dirty="0">
-                <a:solidFill>
-                  <a:srgbClr val="8A6E52"/>
-                </a:solidFill>
-                <a:latin typeface="Arial" pitchFamily="34" charset="0"/>
-                <a:ea typeface="Arial" pitchFamily="34" charset="-122"/>
-                <a:cs typeface="Arial" pitchFamily="34" charset="-120"/>
-              </a:rPr>
-              <a:t>ציוד מתכלה:</a:t>
-            </a:r>
-            <a:endParaRPr lang="he-IL" sz="1600" dirty="0"/>
-          </a:p>
-        </p:txBody>
-      </p:sp>
-      <p:sp>
-        <p:nvSpPr>
-          <p:cNvPr id="11" name="Text 8"/>
-          <p:cNvSpPr/>
-          <p:nvPr/>
-        </p:nvSpPr>
-        <p:spPr>
-          <a:xfrm>
-            <a:off x="868680" y="2148840"/>
-            <a:ext cx="4709160" cy="1371600"/>
-          </a:xfrm>
-          <a:prstGeom prst="rect">
-            <a:avLst/>
-          </a:prstGeom>
-          <a:noFill/>
-          <a:ln/>
-        </p:spPr>
-        <p:txBody>
-          <a:bodyPr wrap="square" lIns="0" tIns="0" rIns="0" bIns="0" rtlCol="0" anchor="t"/>
-          <a:lstStyle/>
-          <a:p>
-            <a:pPr rtl="1" algn="r" indent="0" marL="0">
-              <a:lnSpc>
-                <a:spcPct val="115000"/>
-              </a:lnSpc>
-              <a:spcAft>
-                <a:spcPts val="600"/>
-              </a:spcAft>
-              <a:buNone/>
-            </a:pPr>
-            <a:r>
-              <a:rPr lang="he-IL" altLang="en-US" sz="1450" dirty="0">
-                <a:solidFill>
-                  <a:srgbClr val="26221E"/>
-                </a:solidFill>
-                <a:latin typeface="Arial" pitchFamily="34" charset="0"/>
-                <a:ea typeface="Arial" pitchFamily="34" charset="-122"/>
-                <a:cs typeface="Arial" pitchFamily="34" charset="-120"/>
-              </a:rPr>
-              <a:t>גזות, אלכוהול, קנולות וכו'</a:t>
-            </a:r>
-            <a:endParaRPr lang="he-IL" sz="1450" dirty="0"/>
-          </a:p>
-          <a:p>
-            <a:pPr rtl="1" algn="r" indent="0" marL="0">
-              <a:lnSpc>
-                <a:spcPct val="115000"/>
-              </a:lnSpc>
-              <a:buNone/>
-            </a:pPr>
-            <a:r>
-              <a:rPr lang="he-IL" altLang="en-US" sz="1600" b="1" dirty="0">
-                <a:solidFill>
-                  <a:srgbClr val="26221E"/>
-                </a:solidFill>
-                <a:latin typeface="Arial" pitchFamily="34" charset="0"/>
-                <a:ea typeface="Arial" pitchFamily="34" charset="-122"/>
-                <a:cs typeface="Arial" pitchFamily="34" charset="-120"/>
-              </a:rPr>
-              <a:t>לא עולים יותר מ־50 ש”ח לטיפול</a:t>
-            </a:r>
-            <a:endParaRPr lang="he-IL" sz="1450" dirty="0"/>
-          </a:p>
-        </p:txBody>
-      </p:sp>
-      <p:sp>
-        <p:nvSpPr>
-          <p:cNvPr id="12" name="Text 9"/>
-          <p:cNvSpPr/>
-          <p:nvPr/>
-        </p:nvSpPr>
-        <p:spPr>
-          <a:xfrm>
-            <a:off x="548640" y="4069080"/>
-            <a:ext cx="11091672" cy="457200"/>
-          </a:xfrm>
-          <a:prstGeom prst="rect">
-            <a:avLst/>
-          </a:prstGeom>
-          <a:noFill/>
-          <a:ln/>
-        </p:spPr>
-        <p:txBody>
-          <a:bodyPr wrap="square" lIns="0" tIns="0" rIns="0" bIns="0" rtlCol="0" anchor="t"/>
-          <a:lstStyle/>
-          <a:p>
-            <a:pPr rtl="1" algn="r" indent="0" marL="0">
-              <a:buNone/>
-            </a:pPr>
-            <a:r>
-              <a:rPr lang="he-IL" altLang="en-US" sz="1800" b="1" dirty="0">
-                <a:solidFill>
-                  <a:srgbClr val="26221E"/>
-                </a:solidFill>
-                <a:latin typeface="Arial" pitchFamily="34" charset="0"/>
-                <a:ea typeface="Arial" pitchFamily="34" charset="-122"/>
-                <a:cs typeface="Arial" pitchFamily="34" charset="-120"/>
-              </a:rPr>
-              <a:t>חישוב עלות חומרית – דוגמה לטיפול הוליסטי בשקעי עיניים</a:t>
-            </a:r>
-            <a:endParaRPr lang="he-IL" sz="1800" dirty="0"/>
-          </a:p>
-        </p:txBody>
-      </p:sp>
-      <p:sp>
-        <p:nvSpPr>
-          <p:cNvPr id="13" name="Text 10"/>
-          <p:cNvSpPr/>
-          <p:nvPr/>
-        </p:nvSpPr>
-        <p:spPr>
-          <a:xfrm>
-            <a:off x="548640" y="4617720"/>
-            <a:ext cx="11091672" cy="1188720"/>
+            <a:off x="868680" y="4297680"/>
+            <a:ext cx="10451592" cy="1371600"/>
           </a:xfrm>
           <a:prstGeom prst="rect">
             <a:avLst/>
@@ -10417,12 +10223,12 @@
         </p:nvSpPr>
         <p:spPr>
           <a:xfrm>
-            <a:off x="6245352" y="1554480"/>
-            <a:ext cx="5394960" cy="2103120"/>
+            <a:off x="548640" y="1463040"/>
+            <a:ext cx="11091672" cy="1005840"/>
           </a:xfrm>
           <a:prstGeom prst="roundRect">
             <a:avLst>
-              <a:gd name="adj" fmla="val 4348"/>
+              <a:gd name="adj" fmla="val 9091"/>
             </a:avLst>
           </a:prstGeom>
           <a:solidFill>
@@ -10446,8 +10252,8 @@
         </p:nvSpPr>
         <p:spPr>
           <a:xfrm>
-            <a:off x="6519672" y="1737360"/>
-            <a:ext cx="4846320" cy="457200"/>
+            <a:off x="7040880" y="1463040"/>
+            <a:ext cx="4297680" cy="1005840"/>
           </a:xfrm>
           <a:prstGeom prst="rect">
             <a:avLst/>
@@ -10456,10 +10262,13 @@
           <a:ln/>
         </p:spPr>
         <p:txBody>
-          <a:bodyPr wrap="square" lIns="0" tIns="0" rIns="0" bIns="0" rtlCol="0" anchor="t"/>
+          <a:bodyPr wrap="square" lIns="0" tIns="0" rIns="0" bIns="0" rtlCol="0" anchor="ctr"/>
           <a:lstStyle/>
           <a:p>
             <a:pPr rtl="1" algn="r" indent="0" marL="0">
+              <a:lnSpc>
+                <a:spcPct val="100000"/>
+              </a:lnSpc>
               <a:buNone/>
             </a:pPr>
             <a:r>
@@ -10471,7 +10280,7 @@
                 <a:ea typeface="Arial" pitchFamily="34" charset="-122"/>
                 <a:cs typeface="Arial" pitchFamily="34" charset="-120"/>
               </a:rPr>
-              <a:t>עלות 1 מ”ל סלבוסטר</a:t>
+              <a:t>עלות 1 מ”ל סלבוסטר:</a:t>
             </a:r>
             <a:endParaRPr lang="he-IL" sz="1550" dirty="0"/>
           </a:p>
@@ -10485,8 +10294,8 @@
         </p:nvSpPr>
         <p:spPr>
           <a:xfrm>
-            <a:off x="6519672" y="2267712"/>
-            <a:ext cx="4846320" cy="640080"/>
+            <a:off x="3749040" y="1463040"/>
+            <a:ext cx="3108960" cy="1005840"/>
           </a:xfrm>
           <a:prstGeom prst="rect">
             <a:avLst/>
@@ -10495,14 +10304,14 @@
           <a:ln/>
         </p:spPr>
         <p:txBody>
-          <a:bodyPr wrap="square" lIns="0" tIns="0" rIns="0" bIns="0" rtlCol="0" anchor="t"/>
+          <a:bodyPr wrap="square" lIns="0" tIns="0" rIns="0" bIns="0" rtlCol="0" anchor="ctr"/>
           <a:lstStyle/>
           <a:p>
             <a:pPr rtl="1" algn="r" indent="0" marL="0">
               <a:buNone/>
             </a:pPr>
             <a:r>
-              <a:rPr lang="he-IL" altLang="en-US" sz="2600" b="1" dirty="0">
+              <a:rPr lang="he-IL" altLang="en-US" sz="2100" b="1" dirty="0">
                 <a:solidFill>
                   <a:srgbClr val="26221E"/>
                 </a:solidFill>
@@ -10512,7 +10321,7 @@
               </a:rPr>
               <a:t>83 ש”ח</a:t>
             </a:r>
-            <a:endParaRPr lang="he-IL" sz="2600" dirty="0"/>
+            <a:endParaRPr lang="he-IL" sz="2100" dirty="0"/>
           </a:p>
         </p:txBody>
       </p:sp>
@@ -10524,8 +10333,8 @@
         </p:nvSpPr>
         <p:spPr>
           <a:xfrm>
-            <a:off x="6519672" y="2971800"/>
-            <a:ext cx="4846320" cy="502920"/>
+            <a:off x="868680" y="1463040"/>
+            <a:ext cx="2834640" cy="1005840"/>
           </a:xfrm>
           <a:prstGeom prst="rect">
             <a:avLst/>
@@ -10534,14 +10343,17 @@
           <a:ln/>
         </p:spPr>
         <p:txBody>
-          <a:bodyPr wrap="square" lIns="0" tIns="0" rIns="0" bIns="0" rtlCol="0" anchor="t"/>
+          <a:bodyPr wrap="square" lIns="0" tIns="0" rIns="0" bIns="0" rtlCol="0" anchor="ctr"/>
           <a:lstStyle/>
           <a:p>
             <a:pPr rtl="1" algn="r" indent="0" marL="0">
-              <a:buNone/>
-            </a:pPr>
-            <a:r>
-              <a:rPr lang="he-IL" altLang="en-US" sz="1500" dirty="0">
+              <a:lnSpc>
+                <a:spcPct val="105000"/>
+              </a:lnSpc>
+              <a:buNone/>
+            </a:pPr>
+            <a:r>
+              <a:rPr lang="he-IL" altLang="en-US" sz="1250" dirty="0">
                 <a:solidFill>
                   <a:srgbClr val="6E655B"/>
                 </a:solidFill>
@@ -10551,7 +10363,7 @@
               </a:rPr>
               <a:t>או 60 ש”ח לבוגרי הקורס</a:t>
             </a:r>
-            <a:endParaRPr lang="he-IL" sz="1500" dirty="0"/>
+            <a:endParaRPr lang="he-IL" sz="1250" dirty="0"/>
           </a:p>
         </p:txBody>
       </p:sp>
@@ -10563,12 +10375,12 @@
         </p:nvSpPr>
         <p:spPr>
           <a:xfrm>
-            <a:off x="548640" y="1554480"/>
-            <a:ext cx="5394960" cy="2103120"/>
+            <a:off x="548640" y="2587752"/>
+            <a:ext cx="11091672" cy="1005840"/>
           </a:xfrm>
           <a:prstGeom prst="roundRect">
             <a:avLst>
-              <a:gd name="adj" fmla="val 4348"/>
+              <a:gd name="adj" fmla="val 9091"/>
             </a:avLst>
           </a:prstGeom>
           <a:solidFill>
@@ -10592,8 +10404,8 @@
         </p:nvSpPr>
         <p:spPr>
           <a:xfrm>
-            <a:off x="822960" y="1737360"/>
-            <a:ext cx="4846320" cy="457200"/>
+            <a:off x="7040880" y="2587752"/>
+            <a:ext cx="4297680" cy="1005840"/>
           </a:xfrm>
           <a:prstGeom prst="rect">
             <a:avLst/>
@@ -10602,10 +10414,13 @@
           <a:ln/>
         </p:spPr>
         <p:txBody>
-          <a:bodyPr wrap="square" lIns="0" tIns="0" rIns="0" bIns="0" rtlCol="0" anchor="t"/>
+          <a:bodyPr wrap="square" lIns="0" tIns="0" rIns="0" bIns="0" rtlCol="0" anchor="ctr"/>
           <a:lstStyle/>
           <a:p>
             <a:pPr rtl="1" algn="r" indent="0" marL="0">
+              <a:lnSpc>
+                <a:spcPct val="100000"/>
+              </a:lnSpc>
               <a:buNone/>
             </a:pPr>
             <a:r>
@@ -10617,7 +10432,7 @@
                 <a:ea typeface="Arial" pitchFamily="34" charset="-122"/>
                 <a:cs typeface="Arial" pitchFamily="34" charset="-120"/>
               </a:rPr>
-              <a:t>מזרק מילוי</a:t>
+              <a:t>מזרק מילוי:</a:t>
             </a:r>
             <a:endParaRPr lang="he-IL" sz="1550" dirty="0"/>
           </a:p>
@@ -10631,8 +10446,8 @@
         </p:nvSpPr>
         <p:spPr>
           <a:xfrm>
-            <a:off x="822960" y="2267712"/>
-            <a:ext cx="4846320" cy="640080"/>
+            <a:off x="3749040" y="2587752"/>
+            <a:ext cx="3108960" cy="1005840"/>
           </a:xfrm>
           <a:prstGeom prst="rect">
             <a:avLst/>
@@ -10641,14 +10456,14 @@
           <a:ln/>
         </p:spPr>
         <p:txBody>
-          <a:bodyPr wrap="square" lIns="0" tIns="0" rIns="0" bIns="0" rtlCol="0" anchor="t"/>
+          <a:bodyPr wrap="square" lIns="0" tIns="0" rIns="0" bIns="0" rtlCol="0" anchor="ctr"/>
           <a:lstStyle/>
           <a:p>
             <a:pPr rtl="1" algn="r" indent="0" marL="0">
               <a:buNone/>
             </a:pPr>
             <a:r>
-              <a:rPr lang="he-IL" altLang="en-US" sz="2600" b="1" dirty="0">
+              <a:rPr lang="he-IL" altLang="en-US" sz="2100" b="1" dirty="0">
                 <a:solidFill>
                   <a:srgbClr val="26221E"/>
                 </a:solidFill>
@@ -10658,7 +10473,7 @@
               </a:rPr>
               <a:t>330 ש”ח</a:t>
             </a:r>
-            <a:endParaRPr lang="he-IL" sz="2600" dirty="0"/>
+            <a:endParaRPr lang="he-IL" sz="2100" dirty="0"/>
           </a:p>
         </p:txBody>
       </p:sp>
@@ -10670,8 +10485,8 @@
         </p:nvSpPr>
         <p:spPr>
           <a:xfrm>
-            <a:off x="822960" y="2971800"/>
-            <a:ext cx="4846320" cy="502920"/>
+            <a:off x="868680" y="2587752"/>
+            <a:ext cx="2834640" cy="1005840"/>
           </a:xfrm>
           <a:prstGeom prst="rect">
             <a:avLst/>
@@ -10680,14 +10495,17 @@
           <a:ln/>
         </p:spPr>
         <p:txBody>
-          <a:bodyPr wrap="square" lIns="0" tIns="0" rIns="0" bIns="0" rtlCol="0" anchor="t"/>
+          <a:bodyPr wrap="square" lIns="0" tIns="0" rIns="0" bIns="0" rtlCol="0" anchor="ctr"/>
           <a:lstStyle/>
           <a:p>
             <a:pPr rtl="1" algn="r" indent="0" marL="0">
-              <a:buNone/>
-            </a:pPr>
-            <a:r>
-              <a:rPr lang="he-IL" altLang="en-US" sz="1500" dirty="0">
+              <a:lnSpc>
+                <a:spcPct val="105000"/>
+              </a:lnSpc>
+              <a:buNone/>
+            </a:pPr>
+            <a:r>
+              <a:rPr lang="he-IL" altLang="en-US" sz="1250" dirty="0">
                 <a:solidFill>
                   <a:srgbClr val="6E655B"/>
                 </a:solidFill>
@@ -10697,7 +10515,7 @@
               </a:rPr>
               <a:t>או 250 ש”ח לבוגרים</a:t>
             </a:r>
-            <a:endParaRPr lang="he-IL" sz="1500" dirty="0"/>
+            <a:endParaRPr lang="he-IL" sz="1250" dirty="0"/>
           </a:p>
         </p:txBody>
       </p:sp>
@@ -10709,12 +10527,12 @@
         </p:nvSpPr>
         <p:spPr>
           <a:xfrm>
-            <a:off x="6245352" y="3886200"/>
-            <a:ext cx="5394960" cy="2103120"/>
+            <a:off x="548640" y="3712464"/>
+            <a:ext cx="11091672" cy="1005840"/>
           </a:xfrm>
           <a:prstGeom prst="roundRect">
             <a:avLst>
-              <a:gd name="adj" fmla="val 4348"/>
+              <a:gd name="adj" fmla="val 9091"/>
             </a:avLst>
           </a:prstGeom>
           <a:solidFill>
@@ -10738,8 +10556,8 @@
         </p:nvSpPr>
         <p:spPr>
           <a:xfrm>
-            <a:off x="6519672" y="4069080"/>
-            <a:ext cx="4846320" cy="457200"/>
+            <a:off x="7040880" y="3712464"/>
+            <a:ext cx="4297680" cy="1005840"/>
           </a:xfrm>
           <a:prstGeom prst="rect">
             <a:avLst/>
@@ -10748,10 +10566,13 @@
           <a:ln/>
         </p:spPr>
         <p:txBody>
-          <a:bodyPr wrap="square" lIns="0" tIns="0" rIns="0" bIns="0" rtlCol="0" anchor="t"/>
+          <a:bodyPr wrap="square" lIns="0" tIns="0" rIns="0" bIns="0" rtlCol="0" anchor="ctr"/>
           <a:lstStyle/>
           <a:p>
             <a:pPr rtl="1" algn="r" indent="0" marL="0">
+              <a:lnSpc>
+                <a:spcPct val="100000"/>
+              </a:lnSpc>
               <a:buNone/>
             </a:pPr>
             <a:r>
@@ -10777,8 +10598,8 @@
         </p:nvSpPr>
         <p:spPr>
           <a:xfrm>
-            <a:off x="6519672" y="4599432"/>
-            <a:ext cx="4846320" cy="640080"/>
+            <a:off x="3749040" y="3712464"/>
+            <a:ext cx="3108960" cy="1005840"/>
           </a:xfrm>
           <a:prstGeom prst="rect">
             <a:avLst/>
@@ -10787,14 +10608,14 @@
           <a:ln/>
         </p:spPr>
         <p:txBody>
-          <a:bodyPr wrap="square" lIns="0" tIns="0" rIns="0" bIns="0" rtlCol="0" anchor="t"/>
+          <a:bodyPr wrap="square" lIns="0" tIns="0" rIns="0" bIns="0" rtlCol="0" anchor="ctr"/>
           <a:lstStyle/>
           <a:p>
             <a:pPr rtl="1" algn="r" indent="0" marL="0">
               <a:buNone/>
             </a:pPr>
             <a:r>
-              <a:rPr lang="he-IL" altLang="en-US" sz="2600" b="1" dirty="0">
+              <a:rPr lang="he-IL" altLang="en-US" sz="2100" b="1" dirty="0">
                 <a:solidFill>
                   <a:srgbClr val="26221E"/>
                 </a:solidFill>
@@ -10804,7 +10625,7 @@
               </a:rPr>
               <a:t>רגיל: 413 ש”ח</a:t>
             </a:r>
-            <a:endParaRPr lang="he-IL" sz="2600" dirty="0"/>
+            <a:endParaRPr lang="he-IL" sz="2100" dirty="0"/>
           </a:p>
         </p:txBody>
       </p:sp>
@@ -10816,8 +10637,8 @@
         </p:nvSpPr>
         <p:spPr>
           <a:xfrm>
-            <a:off x="6519672" y="5303520"/>
-            <a:ext cx="4846320" cy="502920"/>
+            <a:off x="868680" y="3712464"/>
+            <a:ext cx="2834640" cy="1005840"/>
           </a:xfrm>
           <a:prstGeom prst="rect">
             <a:avLst/>
@@ -10826,14 +10647,17 @@
           <a:ln/>
         </p:spPr>
         <p:txBody>
-          <a:bodyPr wrap="square" lIns="0" tIns="0" rIns="0" bIns="0" rtlCol="0" anchor="t"/>
+          <a:bodyPr wrap="square" lIns="0" tIns="0" rIns="0" bIns="0" rtlCol="0" anchor="ctr"/>
           <a:lstStyle/>
           <a:p>
             <a:pPr rtl="1" algn="r" indent="0" marL="0">
-              <a:buNone/>
-            </a:pPr>
-            <a:r>
-              <a:rPr lang="he-IL" altLang="en-US" sz="1500" dirty="0">
+              <a:lnSpc>
+                <a:spcPct val="105000"/>
+              </a:lnSpc>
+              <a:buNone/>
+            </a:pPr>
+            <a:r>
+              <a:rPr lang="he-IL" altLang="en-US" sz="1250" dirty="0">
                 <a:solidFill>
                   <a:srgbClr val="6E655B"/>
                 </a:solidFill>
@@ -10843,7 +10667,7 @@
               </a:rPr>
               <a:t>לבוגרי הקורס: 310 ש”ח</a:t>
             </a:r>
-            <a:endParaRPr lang="he-IL" sz="1500" dirty="0"/>
+            <a:endParaRPr lang="he-IL" sz="1250" dirty="0"/>
           </a:p>
         </p:txBody>
       </p:sp>
@@ -10855,12 +10679,12 @@
         </p:nvSpPr>
         <p:spPr>
           <a:xfrm>
-            <a:off x="548640" y="3886200"/>
-            <a:ext cx="5394960" cy="2103120"/>
+            <a:off x="548640" y="4837176"/>
+            <a:ext cx="11091672" cy="1005840"/>
           </a:xfrm>
           <a:prstGeom prst="roundRect">
             <a:avLst>
-              <a:gd name="adj" fmla="val 4348"/>
+              <a:gd name="adj" fmla="val 9091"/>
             </a:avLst>
           </a:prstGeom>
           <a:solidFill>
@@ -10884,8 +10708,8 @@
         </p:nvSpPr>
         <p:spPr>
           <a:xfrm>
-            <a:off x="822960" y="4069080"/>
-            <a:ext cx="4846320" cy="457200"/>
+            <a:off x="7040880" y="4837176"/>
+            <a:ext cx="4297680" cy="1005840"/>
           </a:xfrm>
           <a:prstGeom prst="rect">
             <a:avLst/>
@@ -10894,10 +10718,13 @@
           <a:ln/>
         </p:spPr>
         <p:txBody>
-          <a:bodyPr wrap="square" lIns="0" tIns="0" rIns="0" bIns="0" rtlCol="0" anchor="t"/>
+          <a:bodyPr wrap="square" lIns="0" tIns="0" rIns="0" bIns="0" rtlCol="0" anchor="ctr"/>
           <a:lstStyle/>
           <a:p>
             <a:pPr rtl="1" algn="r" indent="0" marL="0">
+              <a:lnSpc>
+                <a:spcPct val="100000"/>
+              </a:lnSpc>
               <a:buNone/>
             </a:pPr>
             <a:r>
@@ -10909,7 +10736,7 @@
                 <a:ea typeface="Arial" pitchFamily="34" charset="-122"/>
                 <a:cs typeface="Arial" pitchFamily="34" charset="-120"/>
               </a:rPr>
-              <a:t>בתוספת ציוד מתכלה (כ־50 ש”ח)</a:t>
+              <a:t>בתוספת ציוד מתכלה (כ־50 ש”ח):</a:t>
             </a:r>
             <a:endParaRPr lang="he-IL" sz="1550" dirty="0"/>
           </a:p>
@@ -10923,8 +10750,8 @@
         </p:nvSpPr>
         <p:spPr>
           <a:xfrm>
-            <a:off x="822960" y="4599432"/>
-            <a:ext cx="4846320" cy="640080"/>
+            <a:off x="3749040" y="4837176"/>
+            <a:ext cx="3108960" cy="1005840"/>
           </a:xfrm>
           <a:prstGeom prst="rect">
             <a:avLst/>
@@ -10933,14 +10760,14 @@
           <a:ln/>
         </p:spPr>
         <p:txBody>
-          <a:bodyPr wrap="square" lIns="0" tIns="0" rIns="0" bIns="0" rtlCol="0" anchor="t"/>
+          <a:bodyPr wrap="square" lIns="0" tIns="0" rIns="0" bIns="0" rtlCol="0" anchor="ctr"/>
           <a:lstStyle/>
           <a:p>
             <a:pPr rtl="1" algn="r" indent="0" marL="0">
               <a:buNone/>
             </a:pPr>
             <a:r>
-              <a:rPr lang="he-IL" altLang="en-US" sz="2600" b="1" dirty="0">
+              <a:rPr lang="he-IL" altLang="en-US" sz="2100" b="1" dirty="0">
                 <a:solidFill>
                   <a:srgbClr val="FFFFFF"/>
                 </a:solidFill>
@@ -10950,7 +10777,7 @@
               </a:rPr>
               <a:t>רגיל: 463 ש”ח</a:t>
             </a:r>
-            <a:endParaRPr lang="he-IL" sz="2600" dirty="0"/>
+            <a:endParaRPr lang="he-IL" sz="2100" dirty="0"/>
           </a:p>
         </p:txBody>
       </p:sp>
@@ -10962,8 +10789,8 @@
         </p:nvSpPr>
         <p:spPr>
           <a:xfrm>
-            <a:off x="822960" y="5303520"/>
-            <a:ext cx="4846320" cy="502920"/>
+            <a:off x="868680" y="4837176"/>
+            <a:ext cx="2834640" cy="1005840"/>
           </a:xfrm>
           <a:prstGeom prst="rect">
             <a:avLst/>
@@ -10972,14 +10799,17 @@
           <a:ln/>
         </p:spPr>
         <p:txBody>
-          <a:bodyPr wrap="square" lIns="0" tIns="0" rIns="0" bIns="0" rtlCol="0" anchor="t"/>
+          <a:bodyPr wrap="square" lIns="0" tIns="0" rIns="0" bIns="0" rtlCol="0" anchor="ctr"/>
           <a:lstStyle/>
           <a:p>
             <a:pPr rtl="1" algn="r" indent="0" marL="0">
-              <a:buNone/>
-            </a:pPr>
-            <a:r>
-              <a:rPr lang="he-IL" altLang="en-US" sz="1500" dirty="0">
+              <a:lnSpc>
+                <a:spcPct val="105000"/>
+              </a:lnSpc>
+              <a:buNone/>
+            </a:pPr>
+            <a:r>
+              <a:rPr lang="he-IL" altLang="en-US" sz="1250" dirty="0">
                 <a:solidFill>
                   <a:srgbClr val="D8CCBD"/>
                 </a:solidFill>
@@ -10989,7 +10819,7 @@
               </a:rPr>
               <a:t>לבוגרי הקורס: 360 ש”ח</a:t>
             </a:r>
-            <a:endParaRPr lang="he-IL" sz="1500" dirty="0"/>
+            <a:endParaRPr lang="he-IL" sz="1250" dirty="0"/>
           </a:p>
         </p:txBody>
       </p:sp>
@@ -11220,7 +11050,7 @@
         </p:nvSpPr>
         <p:spPr>
           <a:xfrm>
-            <a:off x="548640" y="2240280"/>
+            <a:off x="548640" y="2148840"/>
             <a:ext cx="11091672" cy="411480"/>
           </a:xfrm>
           <a:prstGeom prst="rect">
@@ -11259,12 +11089,12 @@
         </p:nvSpPr>
         <p:spPr>
           <a:xfrm>
-            <a:off x="6245352" y="2743200"/>
-            <a:ext cx="5394960" cy="2148840"/>
+            <a:off x="548640" y="2606040"/>
+            <a:ext cx="11091672" cy="1143000"/>
           </a:xfrm>
           <a:prstGeom prst="roundRect">
             <a:avLst>
-              <a:gd name="adj" fmla="val 4255"/>
+              <a:gd name="adj" fmla="val 8000"/>
             </a:avLst>
           </a:prstGeom>
           <a:solidFill>
@@ -11288,8 +11118,8 @@
         </p:nvSpPr>
         <p:spPr>
           <a:xfrm>
-            <a:off x="6519672" y="2944368"/>
-            <a:ext cx="4846320" cy="502920"/>
+            <a:off x="6400800" y="2606040"/>
+            <a:ext cx="4937760" cy="1143000"/>
           </a:xfrm>
           <a:prstGeom prst="rect">
             <a:avLst/>
@@ -11298,14 +11128,14 @@
           <a:ln/>
         </p:spPr>
         <p:txBody>
-          <a:bodyPr wrap="square" lIns="0" tIns="0" rIns="0" bIns="0" rtlCol="0" anchor="t"/>
+          <a:bodyPr wrap="square" lIns="0" tIns="0" rIns="0" bIns="0" rtlCol="0" anchor="ctr"/>
           <a:lstStyle/>
           <a:p>
             <a:pPr rtl="1" algn="r" indent="0" marL="0">
               <a:buNone/>
             </a:pPr>
             <a:r>
-              <a:rPr lang="he-IL" altLang="en-US" sz="2100" b="1" dirty="0">
+              <a:rPr lang="he-IL" altLang="en-US" sz="1900" b="1" dirty="0">
                 <a:solidFill>
                   <a:srgbClr val="A3866A"/>
                 </a:solidFill>
@@ -11315,7 +11145,7 @@
               </a:rPr>
               <a:t>2000 ש”ח לטיפול מלא</a:t>
             </a:r>
-            <a:endParaRPr lang="he-IL" sz="2100" dirty="0"/>
+            <a:endParaRPr lang="he-IL" sz="1900" dirty="0"/>
           </a:p>
         </p:txBody>
       </p:sp>
@@ -11327,8 +11157,8 @@
         </p:nvSpPr>
         <p:spPr>
           <a:xfrm>
-            <a:off x="6519672" y="3611880"/>
-            <a:ext cx="4846320" cy="1097280"/>
+            <a:off x="868680" y="2606040"/>
+            <a:ext cx="5303520" cy="1143000"/>
           </a:xfrm>
           <a:prstGeom prst="rect">
             <a:avLst/>
@@ -11337,20 +11167,20 @@
           <a:ln/>
         </p:spPr>
         <p:txBody>
-          <a:bodyPr wrap="square" lIns="0" tIns="0" rIns="0" bIns="0" rtlCol="0" anchor="t"/>
+          <a:bodyPr wrap="square" lIns="0" tIns="0" rIns="0" bIns="0" rtlCol="0" anchor="ctr"/>
           <a:lstStyle/>
           <a:p>
             <a:pPr rtl="1" algn="r" indent="0" marL="0">
               <a:lnSpc>
-                <a:spcPct val="115000"/>
+                <a:spcPct val="110000"/>
               </a:lnSpc>
               <a:spcAft>
-                <a:spcPts val="800"/>
+                <a:spcPts val="500"/>
               </a:spcAft>
               <a:buNone/>
             </a:pPr>
             <a:r>
-              <a:rPr lang="he-IL" altLang="en-US" sz="1600" dirty="0">
+              <a:rPr lang="he-IL" altLang="en-US" sz="1450" dirty="0">
                 <a:solidFill>
                   <a:srgbClr val="FFFFFF"/>
                 </a:solidFill>
@@ -11360,17 +11190,17 @@
               </a:rPr>
               <a:t>רווח רגיל: 1,537 ש”ח (76.8%)</a:t>
             </a:r>
-            <a:endParaRPr lang="he-IL" sz="1600" dirty="0"/>
+            <a:endParaRPr lang="he-IL" sz="1450" dirty="0"/>
           </a:p>
           <a:p>
             <a:pPr rtl="1" algn="r" indent="0" marL="0">
               <a:lnSpc>
-                <a:spcPct val="115000"/>
-              </a:lnSpc>
-              <a:buNone/>
-            </a:pPr>
-            <a:r>
-              <a:rPr lang="he-IL" altLang="en-US" sz="1600" b="1" dirty="0">
+                <a:spcPct val="110000"/>
+              </a:lnSpc>
+              <a:buNone/>
+            </a:pPr>
+            <a:r>
+              <a:rPr lang="he-IL" altLang="en-US" sz="1450" b="1" dirty="0">
                 <a:solidFill>
                   <a:srgbClr val="FFFFFF"/>
                 </a:solidFill>
@@ -11380,7 +11210,7 @@
               </a:rPr>
               <a:t>רווח לבוגר קורס: 1,640 ש”ח (82.0%)</a:t>
             </a:r>
-            <a:endParaRPr lang="he-IL" sz="1600" dirty="0"/>
+            <a:endParaRPr lang="he-IL" sz="1450" dirty="0"/>
           </a:p>
         </p:txBody>
       </p:sp>
@@ -11392,12 +11222,12 @@
         </p:nvSpPr>
         <p:spPr>
           <a:xfrm>
-            <a:off x="548640" y="2743200"/>
-            <a:ext cx="5394960" cy="2148840"/>
+            <a:off x="548640" y="3886200"/>
+            <a:ext cx="11091672" cy="1143000"/>
           </a:xfrm>
           <a:prstGeom prst="roundRect">
             <a:avLst>
-              <a:gd name="adj" fmla="val 4255"/>
+              <a:gd name="adj" fmla="val 8000"/>
             </a:avLst>
           </a:prstGeom>
           <a:solidFill>
@@ -11421,8 +11251,8 @@
         </p:nvSpPr>
         <p:spPr>
           <a:xfrm>
-            <a:off x="822960" y="2944368"/>
-            <a:ext cx="4846320" cy="777240"/>
+            <a:off x="6400800" y="3886200"/>
+            <a:ext cx="4937760" cy="1143000"/>
           </a:xfrm>
           <a:prstGeom prst="rect">
             <a:avLst/>
@@ -11431,7 +11261,7 @@
           <a:ln/>
         </p:spPr>
         <p:txBody>
-          <a:bodyPr wrap="square" lIns="0" tIns="0" rIns="0" bIns="0" rtlCol="0" anchor="t"/>
+          <a:bodyPr wrap="square" lIns="0" tIns="0" rIns="0" bIns="0" rtlCol="0" anchor="ctr"/>
           <a:lstStyle/>
           <a:p>
             <a:pPr rtl="1" algn="r" indent="0" marL="0">
@@ -11441,7 +11271,7 @@
               <a:buNone/>
             </a:pPr>
             <a:r>
-              <a:rPr lang="he-IL" altLang="en-US" sz="1700" b="1" dirty="0">
+              <a:rPr lang="he-IL" altLang="en-US" sz="1550" b="1" dirty="0">
                 <a:solidFill>
                   <a:srgbClr val="8A6E52"/>
                 </a:solidFill>
@@ -11451,7 +11281,7 @@
               </a:rPr>
               <a:t>1800 ש”ח למטופלת מתקשה – ועדיין ברווח מצוין</a:t>
             </a:r>
-            <a:endParaRPr lang="he-IL" sz="1700" dirty="0"/>
+            <a:endParaRPr lang="he-IL" sz="1550" dirty="0"/>
           </a:p>
         </p:txBody>
       </p:sp>
@@ -11463,8 +11293,8 @@
         </p:nvSpPr>
         <p:spPr>
           <a:xfrm>
-            <a:off x="822960" y="3749040"/>
-            <a:ext cx="4846320" cy="1005840"/>
+            <a:off x="868680" y="3886200"/>
+            <a:ext cx="5303520" cy="1143000"/>
           </a:xfrm>
           <a:prstGeom prst="rect">
             <a:avLst/>
@@ -11473,20 +11303,20 @@
           <a:ln/>
         </p:spPr>
         <p:txBody>
-          <a:bodyPr wrap="square" lIns="0" tIns="0" rIns="0" bIns="0" rtlCol="0" anchor="t"/>
+          <a:bodyPr wrap="square" lIns="0" tIns="0" rIns="0" bIns="0" rtlCol="0" anchor="ctr"/>
           <a:lstStyle/>
           <a:p>
             <a:pPr rtl="1" algn="r" indent="0" marL="0">
               <a:lnSpc>
-                <a:spcPct val="115000"/>
+                <a:spcPct val="110000"/>
               </a:lnSpc>
               <a:spcAft>
-                <a:spcPts val="800"/>
+                <a:spcPts val="500"/>
               </a:spcAft>
               <a:buNone/>
             </a:pPr>
             <a:r>
-              <a:rPr lang="he-IL" altLang="en-US" sz="1600" dirty="0">
+              <a:rPr lang="he-IL" altLang="en-US" sz="1450" dirty="0">
                 <a:solidFill>
                   <a:srgbClr val="26221E"/>
                 </a:solidFill>
@@ -11496,17 +11326,17 @@
               </a:rPr>
               <a:t>רווח רגיל: 1,337 ש”ח (74.3%)</a:t>
             </a:r>
-            <a:endParaRPr lang="he-IL" sz="1600" dirty="0"/>
+            <a:endParaRPr lang="he-IL" sz="1450" dirty="0"/>
           </a:p>
           <a:p>
             <a:pPr rtl="1" algn="r" indent="0" marL="0">
               <a:lnSpc>
-                <a:spcPct val="115000"/>
-              </a:lnSpc>
-              <a:buNone/>
-            </a:pPr>
-            <a:r>
-              <a:rPr lang="he-IL" altLang="en-US" sz="1600" b="1" dirty="0">
+                <a:spcPct val="110000"/>
+              </a:lnSpc>
+              <a:buNone/>
+            </a:pPr>
+            <a:r>
+              <a:rPr lang="he-IL" altLang="en-US" sz="1450" b="1" dirty="0">
                 <a:solidFill>
                   <a:srgbClr val="26221E"/>
                 </a:solidFill>
@@ -11516,7 +11346,7 @@
               </a:rPr>
               <a:t>רווח לבוגר קורס: 1,440 ש”ח (80.0%)</a:t>
             </a:r>
-            <a:endParaRPr lang="he-IL" sz="1600" dirty="0"/>
+            <a:endParaRPr lang="he-IL" sz="1450" dirty="0"/>
           </a:p>
         </p:txBody>
       </p:sp>
@@ -11528,7 +11358,7 @@
         </p:nvSpPr>
         <p:spPr>
           <a:xfrm>
-            <a:off x="1371600" y="5166360"/>
+            <a:off x="1371600" y="5257800"/>
             <a:ext cx="10268712" cy="1005840"/>
           </a:xfrm>
           <a:prstGeom prst="rect">

</xml_diff>

<commit_message>
media-memory: replace single-modality pricing examples with combined treatment-plan examples (lips+perioral, nasolabial+midface)
Co-Authored-By: Claude Fable 5 <noreply@anthropic.com>
Claude-Session: https://claude.ai/code/session_012oaUYezjbRZg4R6ujPtnYc
</commit_message>
<xml_diff>
--- a/media-memory/2026/08/11bf5ee6-c7c9-42de-98d1-555909805943_BEYOND-THE-PRACTICE-full-refreshed.pptx
+++ b/media-memory/2026/08/11bf5ee6-c7c9-42de-98d1-555909805943_BEYOND-THE-PRACTICE-full-refreshed.pptx
@@ -14098,7 +14098,7 @@
               <a:buNone/>
             </a:pPr>
             <a:r>
-              <a:rPr lang="he-IL" altLang="en-US" sz="2400" b="1" dirty="0">
+              <a:rPr lang="he-IL" altLang="en-US" sz="2300" b="1" dirty="0">
                 <a:solidFill>
                   <a:srgbClr val="26221E"/>
                 </a:solidFill>
@@ -14106,26 +14106,163 @@
                 <a:ea typeface="Arial" pitchFamily="34" charset="-122"/>
                 <a:cs typeface="Arial" pitchFamily="34" charset="-120"/>
               </a:rPr>
-              <a:t>דוגמה נוספת: מילוי שפתיים – אזור מורכב</a:t>
-            </a:r>
-            <a:endParaRPr lang="he-IL" sz="2400" dirty="0"/>
+              <a:t>תוכנית משולבת נוספת: שפתיים והאזור הפריאורלי</a:t>
+            </a:r>
+            <a:endParaRPr lang="he-IL" sz="2300" dirty="0"/>
           </a:p>
         </p:txBody>
       </p:sp>
       <p:sp>
         <p:nvSpPr>
-          <p:cNvPr id="6" name="Shape 3"/>
+          <p:cNvPr id="6" name="Text 3"/>
           <p:cNvSpPr/>
           <p:nvPr/>
         </p:nvSpPr>
         <p:spPr>
           <a:xfrm>
-            <a:off x="548640" y="1371600"/>
-            <a:ext cx="11091672" cy="1600200"/>
+            <a:off x="548640" y="1188720"/>
+            <a:ext cx="11091672" cy="1554480"/>
+          </a:xfrm>
+          <a:prstGeom prst="rect">
+            <a:avLst/>
+          </a:prstGeom>
+          <a:noFill/>
+          <a:ln/>
+        </p:spPr>
+        <p:txBody>
+          <a:bodyPr wrap="square" lIns="0" tIns="0" rIns="0" bIns="0" rtlCol="0" anchor="t"/>
+          <a:lstStyle/>
+          <a:p>
+            <a:pPr rtl="1" algn="r" indent="0" marL="0">
+              <a:lnSpc>
+                <a:spcPct val="112000"/>
+              </a:lnSpc>
+              <a:spcAft>
+                <a:spcPts val="400"/>
+              </a:spcAft>
+              <a:buNone/>
+            </a:pPr>
+            <a:r>
+              <a:rPr lang="he-IL" altLang="en-US" sz="1350" dirty="0">
+                <a:solidFill>
+                  <a:srgbClr val="26221E"/>
+                </a:solidFill>
+                <a:latin typeface="Arial" pitchFamily="34" charset="0"/>
+                <a:ea typeface="Arial" pitchFamily="34" charset="-122"/>
+                <a:cs typeface="Arial" pitchFamily="34" charset="-120"/>
+              </a:rPr>
+              <a:t>מטופלת מבקשת “רק מילוי שפתיים”</a:t>
+            </a:r>
+            <a:endParaRPr lang="he-IL" sz="1350" dirty="0"/>
+          </a:p>
+          <a:p>
+            <a:pPr rtl="1" algn="r" indent="0" marL="0">
+              <a:lnSpc>
+                <a:spcPct val="112000"/>
+              </a:lnSpc>
+              <a:spcAft>
+                <a:spcPts val="600"/>
+              </a:spcAft>
+              <a:buNone/>
+            </a:pPr>
+            <a:r>
+              <a:rPr lang="he-IL" altLang="en-US" sz="1350" b="1" dirty="0">
+                <a:solidFill>
+                  <a:srgbClr val="26221E"/>
+                </a:solidFill>
+                <a:latin typeface="Arial" pitchFamily="34" charset="0"/>
+                <a:ea typeface="Arial" pitchFamily="34" charset="-122"/>
+                <a:cs typeface="Arial" pitchFamily="34" charset="-120"/>
+              </a:rPr>
+              <a:t>במקום מזרק בודד – תוכנית הוליסטית לכל האזור:</a:t>
+            </a:r>
+            <a:endParaRPr lang="he-IL" sz="1350" dirty="0"/>
+          </a:p>
+          <a:p>
+            <a:pPr rtl="1" algn="r" marL="342900" indent="-342900">
+              <a:lnSpc>
+                <a:spcPct val="112000"/>
+              </a:lnSpc>
+              <a:spcAft>
+                <a:spcPts val="400"/>
+              </a:spcAft>
+              <a:buSzPct val="100000"/>
+              <a:buChar char="•"/>
+            </a:pPr>
+            <a:r>
+              <a:rPr lang="he-IL" altLang="en-US" sz="1350" dirty="0">
+                <a:solidFill>
+                  <a:srgbClr val="26221E"/>
+                </a:solidFill>
+                <a:latin typeface="Arial" pitchFamily="34" charset="0"/>
+                <a:ea typeface="Arial" pitchFamily="34" charset="-122"/>
+                <a:cs typeface="Arial" pitchFamily="34" charset="-120"/>
+              </a:rPr>
+              <a:t>מילוי מדויק של השפתיים – נפח, הגדרה וסימטריה (מזרק חומצה היאלורונית, אזור מורכב)</a:t>
+            </a:r>
+            <a:endParaRPr lang="he-IL" sz="1350" dirty="0"/>
+          </a:p>
+          <a:p>
+            <a:pPr rtl="1" algn="r" marL="342900" indent="-342900">
+              <a:lnSpc>
+                <a:spcPct val="112000"/>
+              </a:lnSpc>
+              <a:spcAft>
+                <a:spcPts val="400"/>
+              </a:spcAft>
+              <a:buSzPct val="100000"/>
+              <a:buChar char="•"/>
+            </a:pPr>
+            <a:r>
+              <a:rPr lang="he-IL" altLang="en-US" sz="1350" dirty="0">
+                <a:solidFill>
+                  <a:srgbClr val="26221E"/>
+                </a:solidFill>
+                <a:latin typeface="Arial" pitchFamily="34" charset="0"/>
+                <a:ea typeface="Arial" pitchFamily="34" charset="-122"/>
+                <a:cs typeface="Arial" pitchFamily="34" charset="-120"/>
+              </a:rPr>
+              <a:t>סלבוסטר סביב הפה – שיפור מרקם העור וטיפול בקמטוטים הפריאורליים (1 מ”ל)</a:t>
+            </a:r>
+            <a:endParaRPr lang="he-IL" sz="1350" dirty="0"/>
+          </a:p>
+          <a:p>
+            <a:pPr rtl="1" algn="r" marL="342900" indent="-342900">
+              <a:lnSpc>
+                <a:spcPct val="112000"/>
+              </a:lnSpc>
+              <a:buSzPct val="100000"/>
+              <a:buChar char="•"/>
+            </a:pPr>
+            <a:r>
+              <a:rPr lang="he-IL" altLang="en-US" sz="1350" dirty="0">
+                <a:solidFill>
+                  <a:srgbClr val="26221E"/>
+                </a:solidFill>
+                <a:latin typeface="Arial" pitchFamily="34" charset="0"/>
+                <a:ea typeface="Arial" pitchFamily="34" charset="-122"/>
+                <a:cs typeface="Arial" pitchFamily="34" charset="-120"/>
+              </a:rPr>
+              <a:t>איזון זוויות הפה – חלוקת החומר לפי המבנה, לא רק “למלא שפה”</a:t>
+            </a:r>
+            <a:endParaRPr lang="he-IL" sz="1350" dirty="0"/>
+          </a:p>
+        </p:txBody>
+      </p:sp>
+      <p:sp>
+        <p:nvSpPr>
+          <p:cNvPr id="7" name="Shape 4"/>
+          <p:cNvSpPr/>
+          <p:nvPr/>
+        </p:nvSpPr>
+        <p:spPr>
+          <a:xfrm>
+            <a:off x="548640" y="2788920"/>
+            <a:ext cx="11091672" cy="868680"/>
           </a:xfrm>
           <a:prstGeom prst="roundRect">
             <a:avLst>
-              <a:gd name="adj" fmla="val 5714"/>
+              <a:gd name="adj" fmla="val 10526"/>
             </a:avLst>
           </a:prstGeom>
           <a:solidFill>
@@ -14143,14 +14280,14 @@
       </p:sp>
       <p:sp>
         <p:nvSpPr>
-          <p:cNvPr id="7" name="Text 4"/>
+          <p:cNvPr id="8" name="Text 5"/>
           <p:cNvSpPr/>
           <p:nvPr/>
         </p:nvSpPr>
         <p:spPr>
           <a:xfrm>
-            <a:off x="868680" y="1572768"/>
-            <a:ext cx="10451592" cy="1234440"/>
+            <a:off x="868680" y="2788920"/>
+            <a:ext cx="10451592" cy="868680"/>
           </a:xfrm>
           <a:prstGeom prst="rect">
             <a:avLst/>
@@ -14159,63 +14296,17 @@
           <a:ln/>
         </p:spPr>
         <p:txBody>
-          <a:bodyPr wrap="square" lIns="0" tIns="0" rIns="0" bIns="0" rtlCol="0" anchor="t"/>
+          <a:bodyPr wrap="square" lIns="0" tIns="0" rIns="0" bIns="0" rtlCol="0" anchor="ctr"/>
           <a:lstStyle/>
           <a:p>
             <a:pPr rtl="1" algn="r" indent="0" marL="0">
               <a:lnSpc>
-                <a:spcPct val="114000"/>
-              </a:lnSpc>
-              <a:spcAft>
-                <a:spcPts val="600"/>
-              </a:spcAft>
-              <a:buNone/>
-            </a:pPr>
-            <a:r>
-              <a:rPr lang="he-IL" altLang="en-US" sz="1450" b="1" dirty="0">
-                <a:solidFill>
-                  <a:srgbClr val="8A6E52"/>
-                </a:solidFill>
-                <a:latin typeface="Arial" pitchFamily="34" charset="0"/>
-                <a:ea typeface="Arial" pitchFamily="34" charset="-122"/>
-                <a:cs typeface="Arial" pitchFamily="34" charset="-120"/>
-              </a:rPr>
-              <a:t>עלות חומרים</a:t>
-            </a:r>
-            <a:endParaRPr lang="he-IL" sz="1450" dirty="0"/>
-          </a:p>
-          <a:p>
-            <a:pPr rtl="1" algn="r" indent="0" marL="0">
-              <a:lnSpc>
-                <a:spcPct val="114000"/>
-              </a:lnSpc>
-              <a:spcAft>
-                <a:spcPts val="500"/>
-              </a:spcAft>
-              <a:buNone/>
-            </a:pPr>
-            <a:r>
-              <a:rPr lang="he-IL" altLang="en-US" sz="1450" dirty="0">
-                <a:solidFill>
-                  <a:srgbClr val="26221E"/>
-                </a:solidFill>
-                <a:latin typeface="Arial" pitchFamily="34" charset="0"/>
-                <a:ea typeface="Arial" pitchFamily="34" charset="-122"/>
-                <a:cs typeface="Arial" pitchFamily="34" charset="-120"/>
-              </a:rPr>
-              <a:t>מזרק מילוי: 330 ש”ח (או 250 ש”ח לבוגרי הקורס) + ציוד מתכלה: כ־50 ש”ח</a:t>
-            </a:r>
-            <a:endParaRPr lang="he-IL" sz="1450" dirty="0"/>
-          </a:p>
-          <a:p>
-            <a:pPr rtl="1" algn="r" indent="0" marL="0">
-              <a:lnSpc>
-                <a:spcPct val="114000"/>
+                <a:spcPct val="110000"/>
               </a:lnSpc>
               <a:buNone/>
             </a:pPr>
             <a:r>
-              <a:rPr lang="he-IL" altLang="en-US" sz="1450" b="1" dirty="0">
+              <a:rPr lang="he-IL" altLang="en-US" sz="1400" b="1" dirty="0">
                 <a:solidFill>
                   <a:srgbClr val="26221E"/>
                 </a:solidFill>
@@ -14223,26 +14314,26 @@
                 <a:ea typeface="Arial" pitchFamily="34" charset="-122"/>
                 <a:cs typeface="Arial" pitchFamily="34" charset="-120"/>
               </a:rPr>
-              <a:t>סה”כ עלות: 380 ש”ח | לבוגרי הקורס: 300 ש”ח</a:t>
-            </a:r>
-            <a:endParaRPr lang="he-IL" sz="1450" dirty="0"/>
+              <a:t>עלות חומרים: מזרק מילוי 330 + סלבוסטר 1 מ”ל 83 + ציוד מתכלה כ־50 = 463 ש”ח | לבוגרי הקורס: 360 ש”ח</a:t>
+            </a:r>
+            <a:endParaRPr lang="he-IL" sz="1400" dirty="0"/>
           </a:p>
         </p:txBody>
       </p:sp>
       <p:sp>
         <p:nvSpPr>
-          <p:cNvPr id="8" name="Shape 5"/>
+          <p:cNvPr id="9" name="Shape 6"/>
           <p:cNvSpPr/>
           <p:nvPr/>
         </p:nvSpPr>
         <p:spPr>
           <a:xfrm>
-            <a:off x="548640" y="3108960"/>
-            <a:ext cx="11091672" cy="1234440"/>
+            <a:off x="548640" y="3794760"/>
+            <a:ext cx="11091672" cy="1051560"/>
           </a:xfrm>
           <a:prstGeom prst="roundRect">
             <a:avLst>
-              <a:gd name="adj" fmla="val 7407"/>
+              <a:gd name="adj" fmla="val 8696"/>
             </a:avLst>
           </a:prstGeom>
           <a:solidFill>
@@ -14260,14 +14351,14 @@
       </p:sp>
       <p:sp>
         <p:nvSpPr>
-          <p:cNvPr id="9" name="Text 6"/>
+          <p:cNvPr id="10" name="Text 7"/>
           <p:cNvSpPr/>
           <p:nvPr/>
         </p:nvSpPr>
         <p:spPr>
           <a:xfrm>
-            <a:off x="868680" y="3310128"/>
-            <a:ext cx="10451592" cy="914400"/>
+            <a:off x="868680" y="3931920"/>
+            <a:ext cx="10451592" cy="822960"/>
           </a:xfrm>
           <a:prstGeom prst="rect">
             <a:avLst/>
@@ -14281,62 +14372,62 @@
           <a:p>
             <a:pPr rtl="1" algn="r" indent="0" marL="0">
               <a:lnSpc>
-                <a:spcPct val="114000"/>
+                <a:spcPct val="112000"/>
               </a:lnSpc>
               <a:spcAft>
-                <a:spcPts val="600"/>
+                <a:spcPts val="500"/>
               </a:spcAft>
               <a:buNone/>
             </a:pPr>
             <a:r>
-              <a:rPr lang="he-IL" altLang="en-US" sz="1450" b="1" dirty="0">
-                <a:solidFill>
-                  <a:srgbClr val="8A6E52"/>
-                </a:solidFill>
-                <a:latin typeface="Arial" pitchFamily="34" charset="0"/>
-                <a:ea typeface="Arial" pitchFamily="34" charset="-122"/>
-                <a:cs typeface="Arial" pitchFamily="34" charset="-120"/>
-              </a:rPr>
-              <a:t>מחיר למטופלת – לפי המחירון המומלץ</a:t>
-            </a:r>
-            <a:endParaRPr lang="he-IL" sz="1450" dirty="0"/>
+              <a:rPr lang="he-IL" altLang="en-US" sz="1400" dirty="0">
+                <a:solidFill>
+                  <a:srgbClr val="26221E"/>
+                </a:solidFill>
+                <a:latin typeface="Arial" pitchFamily="34" charset="0"/>
+                <a:ea typeface="Arial" pitchFamily="34" charset="-122"/>
+                <a:cs typeface="Arial" pitchFamily="34" charset="-120"/>
+              </a:rPr>
+              <a:t>בנפרד לפי המחירון: מילוי שפתיים 1,800 ₪ + סלבוסטר 1,500 ₪ = 3,300 ₪</a:t>
+            </a:r>
+            <a:endParaRPr lang="he-IL" sz="1400" dirty="0"/>
           </a:p>
           <a:p>
             <a:pPr rtl="1" algn="r" indent="0" marL="0">
               <a:lnSpc>
-                <a:spcPct val="114000"/>
+                <a:spcPct val="112000"/>
               </a:lnSpc>
               <a:buNone/>
             </a:pPr>
             <a:r>
-              <a:rPr lang="he-IL" altLang="en-US" sz="1900" b="1" dirty="0">
-                <a:solidFill>
-                  <a:srgbClr val="26221E"/>
-                </a:solidFill>
-                <a:latin typeface="Arial" pitchFamily="34" charset="0"/>
-                <a:ea typeface="Arial" pitchFamily="34" charset="-122"/>
-                <a:cs typeface="Arial" pitchFamily="34" charset="-120"/>
-              </a:rPr>
-              <a:t>מזרק אחד, אזור מורכב: 1,800 ₪</a:t>
-            </a:r>
-            <a:endParaRPr lang="he-IL" sz="1450" dirty="0"/>
+              <a:rPr lang="he-IL" altLang="en-US" sz="1400" b="1" dirty="0">
+                <a:solidFill>
+                  <a:srgbClr val="8A6E52"/>
+                </a:solidFill>
+                <a:latin typeface="Arial" pitchFamily="34" charset="0"/>
+                <a:ea typeface="Arial" pitchFamily="34" charset="-122"/>
+                <a:cs typeface="Arial" pitchFamily="34" charset="-120"/>
+              </a:rPr>
+              <a:t>מחיר מומלץ לתוכנית המשולבת: 2,500 ₪ – המטופלת מקבלת תוכנית שלמה במחיר משתלם</a:t>
+            </a:r>
+            <a:endParaRPr lang="he-IL" sz="1400" dirty="0"/>
           </a:p>
         </p:txBody>
       </p:sp>
       <p:sp>
         <p:nvSpPr>
-          <p:cNvPr id="10" name="Shape 7"/>
+          <p:cNvPr id="11" name="Shape 8"/>
           <p:cNvSpPr/>
           <p:nvPr/>
         </p:nvSpPr>
         <p:spPr>
           <a:xfrm>
-            <a:off x="548640" y="4480560"/>
-            <a:ext cx="11091672" cy="1417320"/>
+            <a:off x="548640" y="4983480"/>
+            <a:ext cx="11091672" cy="1051560"/>
           </a:xfrm>
           <a:prstGeom prst="roundRect">
             <a:avLst>
-              <a:gd name="adj" fmla="val 6452"/>
+              <a:gd name="adj" fmla="val 8696"/>
             </a:avLst>
           </a:prstGeom>
           <a:solidFill>
@@ -14354,14 +14445,14 @@
       </p:sp>
       <p:sp>
         <p:nvSpPr>
-          <p:cNvPr id="11" name="Text 8"/>
+          <p:cNvPr id="12" name="Text 9"/>
           <p:cNvSpPr/>
           <p:nvPr/>
         </p:nvSpPr>
         <p:spPr>
           <a:xfrm>
-            <a:off x="868680" y="4663440"/>
-            <a:ext cx="10451592" cy="1097280"/>
+            <a:off x="868680" y="5120640"/>
+            <a:ext cx="10451592" cy="822960"/>
           </a:xfrm>
           <a:prstGeom prst="rect">
             <a:avLst/>
@@ -14378,35 +14469,12 @@
                 <a:spcPct val="112000"/>
               </a:lnSpc>
               <a:spcAft>
-                <a:spcPts val="600"/>
+                <a:spcPts val="500"/>
               </a:spcAft>
               <a:buNone/>
             </a:pPr>
             <a:r>
-              <a:rPr lang="he-IL" altLang="en-US" sz="1450" b="1" dirty="0">
-                <a:solidFill>
-                  <a:srgbClr val="A3866A"/>
-                </a:solidFill>
-                <a:latin typeface="Arial" pitchFamily="34" charset="0"/>
-                <a:ea typeface="Arial" pitchFamily="34" charset="-122"/>
-                <a:cs typeface="Arial" pitchFamily="34" charset="-120"/>
-              </a:rPr>
-              <a:t>הרווח שלכם</a:t>
-            </a:r>
-            <a:endParaRPr lang="he-IL" sz="1450" dirty="0"/>
-          </a:p>
-          <a:p>
-            <a:pPr rtl="1" algn="r" indent="0" marL="0">
-              <a:lnSpc>
-                <a:spcPct val="112000"/>
-              </a:lnSpc>
-              <a:spcAft>
-                <a:spcPts val="400"/>
-              </a:spcAft>
-              <a:buNone/>
-            </a:pPr>
-            <a:r>
-              <a:rPr lang="he-IL" altLang="en-US" sz="1450" dirty="0">
+              <a:rPr lang="he-IL" altLang="en-US" sz="1350" b="1" dirty="0">
                 <a:solidFill>
                   <a:srgbClr val="FFFFFF"/>
                 </a:solidFill>
@@ -14414,9 +14482,9 @@
                 <a:ea typeface="Arial" pitchFamily="34" charset="-122"/>
                 <a:cs typeface="Arial" pitchFamily="34" charset="-120"/>
               </a:rPr>
-              <a:t>רווח רגיל: 1,420 ש”ח (78.9%)</a:t>
-            </a:r>
-            <a:endParaRPr lang="he-IL" sz="1450" dirty="0"/>
+              <a:t>רווח רגיל: 2,037 ש”ח (81.5%) | לבוגר קורס: 2,140 ש”ח (85.6%)</a:t>
+            </a:r>
+            <a:endParaRPr lang="he-IL" sz="1350" dirty="0"/>
           </a:p>
           <a:p>
             <a:pPr rtl="1" algn="r" indent="0" marL="0">
@@ -14426,17 +14494,17 @@
               <a:buNone/>
             </a:pPr>
             <a:r>
-              <a:rPr lang="he-IL" altLang="en-US" sz="1450" b="1" dirty="0">
-                <a:solidFill>
-                  <a:srgbClr val="FFFFFF"/>
-                </a:solidFill>
-                <a:latin typeface="Arial" pitchFamily="34" charset="0"/>
-                <a:ea typeface="Arial" pitchFamily="34" charset="-122"/>
-                <a:cs typeface="Arial" pitchFamily="34" charset="-120"/>
-              </a:rPr>
-              <a:t>רווח לבוגר קורס: 1,500 ש”ח (83.3%)</a:t>
-            </a:r>
-            <a:endParaRPr lang="he-IL" sz="1450" dirty="0"/>
+              <a:rPr lang="he-IL" altLang="en-US" sz="1350" dirty="0">
+                <a:solidFill>
+                  <a:srgbClr val="A3866A"/>
+                </a:solidFill>
+                <a:latin typeface="Arial" pitchFamily="34" charset="0"/>
+                <a:ea typeface="Arial" pitchFamily="34" charset="-122"/>
+                <a:cs typeface="Arial" pitchFamily="34" charset="-120"/>
+              </a:rPr>
+              <a:t>כמעט פי 1.5 מהרווח על מזרק שפתיים בודד – עם תוצאה מקיפה יותר ופתח להמשכיות.</a:t>
+            </a:r>
+            <a:endParaRPr lang="he-IL" sz="1350" dirty="0"/>
           </a:p>
         </p:txBody>
       </p:sp>
@@ -14580,7 +14648,7 @@
               <a:buNone/>
             </a:pPr>
             <a:r>
-              <a:rPr lang="he-IL" altLang="en-US" sz="2400" b="1" dirty="0">
+              <a:rPr lang="he-IL" altLang="en-US" sz="2300" b="1" dirty="0">
                 <a:solidFill>
                   <a:srgbClr val="26221E"/>
                 </a:solidFill>
@@ -14588,26 +14656,163 @@
                 <a:ea typeface="Arial" pitchFamily="34" charset="-122"/>
                 <a:cs typeface="Arial" pitchFamily="34" charset="-120"/>
               </a:rPr>
-              <a:t>דוגמה נוספת: סדרת סלבוסטר – הכוח של סדרה</a:t>
-            </a:r>
-            <a:endParaRPr lang="he-IL" sz="2400" dirty="0"/>
+              <a:t>תוכנית משולבת נוספת: קמטי נאזולביאל ונפח הפנים</a:t>
+            </a:r>
+            <a:endParaRPr lang="he-IL" sz="2300" dirty="0"/>
           </a:p>
         </p:txBody>
       </p:sp>
       <p:sp>
         <p:nvSpPr>
-          <p:cNvPr id="6" name="Shape 3"/>
+          <p:cNvPr id="6" name="Text 3"/>
           <p:cNvSpPr/>
           <p:nvPr/>
         </p:nvSpPr>
         <p:spPr>
           <a:xfrm>
-            <a:off x="548640" y="1371600"/>
-            <a:ext cx="11091672" cy="1783080"/>
+            <a:off x="548640" y="1188720"/>
+            <a:ext cx="11091672" cy="1554480"/>
+          </a:xfrm>
+          <a:prstGeom prst="rect">
+            <a:avLst/>
+          </a:prstGeom>
+          <a:noFill/>
+          <a:ln/>
+        </p:spPr>
+        <p:txBody>
+          <a:bodyPr wrap="square" lIns="0" tIns="0" rIns="0" bIns="0" rtlCol="0" anchor="t"/>
+          <a:lstStyle/>
+          <a:p>
+            <a:pPr rtl="1" algn="r" indent="0" marL="0">
+              <a:lnSpc>
+                <a:spcPct val="112000"/>
+              </a:lnSpc>
+              <a:spcAft>
+                <a:spcPts val="400"/>
+              </a:spcAft>
+              <a:buNone/>
+            </a:pPr>
+            <a:r>
+              <a:rPr lang="he-IL" altLang="en-US" sz="1350" dirty="0">
+                <a:solidFill>
+                  <a:srgbClr val="26221E"/>
+                </a:solidFill>
+                <a:latin typeface="Arial" pitchFamily="34" charset="0"/>
+                <a:ea typeface="Arial" pitchFamily="34" charset="-122"/>
+                <a:cs typeface="Arial" pitchFamily="34" charset="-120"/>
+              </a:rPr>
+              <a:t>מטופלת מבקשת מזרק אחד לקמט הנאזולביאלי</a:t>
+            </a:r>
+            <a:endParaRPr lang="he-IL" sz="1350" dirty="0"/>
+          </a:p>
+          <a:p>
+            <a:pPr rtl="1" algn="r" indent="0" marL="0">
+              <a:lnSpc>
+                <a:spcPct val="112000"/>
+              </a:lnSpc>
+              <a:spcAft>
+                <a:spcPts val="600"/>
+              </a:spcAft>
+              <a:buNone/>
+            </a:pPr>
+            <a:r>
+              <a:rPr lang="he-IL" altLang="en-US" sz="1350" b="1" dirty="0">
+                <a:solidFill>
+                  <a:srgbClr val="26221E"/>
+                </a:solidFill>
+                <a:latin typeface="Arial" pitchFamily="34" charset="0"/>
+                <a:ea typeface="Arial" pitchFamily="34" charset="-122"/>
+                <a:cs typeface="Arial" pitchFamily="34" charset="-120"/>
+              </a:rPr>
+              <a:t>אבל הקמט הוא הסימפטום – המקור הוא איבוד נפח בעצמות הלחיים:</a:t>
+            </a:r>
+            <a:endParaRPr lang="he-IL" sz="1350" dirty="0"/>
+          </a:p>
+          <a:p>
+            <a:pPr rtl="1" algn="r" marL="342900" indent="-342900">
+              <a:lnSpc>
+                <a:spcPct val="112000"/>
+              </a:lnSpc>
+              <a:spcAft>
+                <a:spcPts val="400"/>
+              </a:spcAft>
+              <a:buSzPct val="100000"/>
+              <a:buChar char="•"/>
+            </a:pPr>
+            <a:r>
+              <a:rPr lang="he-IL" altLang="en-US" sz="1350" dirty="0">
+                <a:solidFill>
+                  <a:srgbClr val="26221E"/>
+                </a:solidFill>
+                <a:latin typeface="Arial" pitchFamily="34" charset="0"/>
+                <a:ea typeface="Arial" pitchFamily="34" charset="-122"/>
+                <a:cs typeface="Arial" pitchFamily="34" charset="-120"/>
+              </a:rPr>
+              <a:t>שחזור נפח בעצמות הלחיים – טיפול במקור הנפילה (מזרק חומצה היאלורונית)</a:t>
+            </a:r>
+            <a:endParaRPr lang="he-IL" sz="1350" dirty="0"/>
+          </a:p>
+          <a:p>
+            <a:pPr rtl="1" algn="r" marL="342900" indent="-342900">
+              <a:lnSpc>
+                <a:spcPct val="112000"/>
+              </a:lnSpc>
+              <a:spcAft>
+                <a:spcPts val="400"/>
+              </a:spcAft>
+              <a:buSzPct val="100000"/>
+              <a:buChar char="•"/>
+            </a:pPr>
+            <a:r>
+              <a:rPr lang="he-IL" altLang="en-US" sz="1350" dirty="0">
+                <a:solidFill>
+                  <a:srgbClr val="26221E"/>
+                </a:solidFill>
+                <a:latin typeface="Arial" pitchFamily="34" charset="0"/>
+                <a:ea typeface="Arial" pitchFamily="34" charset="-122"/>
+                <a:cs typeface="Arial" pitchFamily="34" charset="-120"/>
+              </a:rPr>
+              <a:t>השלמת מילוי עדינה בקמט עצמו, במידת הצורך (מזרק שני)</a:t>
+            </a:r>
+            <a:endParaRPr lang="he-IL" sz="1350" dirty="0"/>
+          </a:p>
+          <a:p>
+            <a:pPr rtl="1" algn="r" marL="342900" indent="-342900">
+              <a:lnSpc>
+                <a:spcPct val="112000"/>
+              </a:lnSpc>
+              <a:buSzPct val="100000"/>
+              <a:buChar char="•"/>
+            </a:pPr>
+            <a:r>
+              <a:rPr lang="he-IL" altLang="en-US" sz="1350" dirty="0">
+                <a:solidFill>
+                  <a:srgbClr val="26221E"/>
+                </a:solidFill>
+                <a:latin typeface="Arial" pitchFamily="34" charset="0"/>
+                <a:ea typeface="Arial" pitchFamily="34" charset="-122"/>
+                <a:cs typeface="Arial" pitchFamily="34" charset="-120"/>
+              </a:rPr>
+              <a:t>סלבוסטר – שיפור מרקם, לחות ואלסטיות של העור באזור (1 מ”ל)</a:t>
+            </a:r>
+            <a:endParaRPr lang="he-IL" sz="1350" dirty="0"/>
+          </a:p>
+        </p:txBody>
+      </p:sp>
+      <p:sp>
+        <p:nvSpPr>
+          <p:cNvPr id="7" name="Shape 4"/>
+          <p:cNvSpPr/>
+          <p:nvPr/>
+        </p:nvSpPr>
+        <p:spPr>
+          <a:xfrm>
+            <a:off x="548640" y="2788920"/>
+            <a:ext cx="11091672" cy="868680"/>
           </a:xfrm>
           <a:prstGeom prst="roundRect">
             <a:avLst>
-              <a:gd name="adj" fmla="val 5128"/>
+              <a:gd name="adj" fmla="val 10526"/>
             </a:avLst>
           </a:prstGeom>
           <a:solidFill>
@@ -14625,14 +14830,14 @@
       </p:sp>
       <p:sp>
         <p:nvSpPr>
-          <p:cNvPr id="7" name="Text 4"/>
+          <p:cNvPr id="8" name="Text 5"/>
           <p:cNvSpPr/>
           <p:nvPr/>
         </p:nvSpPr>
         <p:spPr>
           <a:xfrm>
-            <a:off x="868680" y="1572768"/>
-            <a:ext cx="10451592" cy="1463040"/>
+            <a:off x="868680" y="2788920"/>
+            <a:ext cx="10451592" cy="868680"/>
           </a:xfrm>
           <a:prstGeom prst="rect">
             <a:avLst/>
@@ -14641,81 +14846,12 @@
           <a:ln/>
         </p:spPr>
         <p:txBody>
-          <a:bodyPr wrap="square" lIns="0" tIns="0" rIns="0" bIns="0" rtlCol="0" anchor="t"/>
+          <a:bodyPr wrap="square" lIns="0" tIns="0" rIns="0" bIns="0" rtlCol="0" anchor="ctr"/>
           <a:lstStyle/>
           <a:p>
             <a:pPr rtl="1" algn="r" indent="0" marL="0">
               <a:lnSpc>
-                <a:spcPct val="112000"/>
-              </a:lnSpc>
-              <a:spcAft>
-                <a:spcPts val="600"/>
-              </a:spcAft>
-              <a:buNone/>
-            </a:pPr>
-            <a:r>
-              <a:rPr lang="he-IL" altLang="en-US" sz="1400" b="1" dirty="0">
-                <a:solidFill>
-                  <a:srgbClr val="8A6E52"/>
-                </a:solidFill>
-                <a:latin typeface="Arial" pitchFamily="34" charset="0"/>
-                <a:ea typeface="Arial" pitchFamily="34" charset="-122"/>
-                <a:cs typeface="Arial" pitchFamily="34" charset="-120"/>
-              </a:rPr>
-              <a:t>עלות חומרים לסדרה של 3 טיפולים</a:t>
-            </a:r>
-            <a:endParaRPr lang="he-IL" sz="1400" dirty="0"/>
-          </a:p>
-          <a:p>
-            <a:pPr rtl="1" algn="r" indent="0" marL="0">
-              <a:lnSpc>
-                <a:spcPct val="112000"/>
-              </a:lnSpc>
-              <a:spcAft>
-                <a:spcPts val="500"/>
-              </a:spcAft>
-              <a:buNone/>
-            </a:pPr>
-            <a:r>
-              <a:rPr lang="he-IL" altLang="en-US" sz="1400" dirty="0">
-                <a:solidFill>
-                  <a:srgbClr val="26221E"/>
-                </a:solidFill>
-                <a:latin typeface="Arial" pitchFamily="34" charset="0"/>
-                <a:ea typeface="Arial" pitchFamily="34" charset="-122"/>
-                <a:cs typeface="Arial" pitchFamily="34" charset="-120"/>
-              </a:rPr>
-              <a:t>בקבוקון סלבוסטר (3 מ”ל): 250 ש”ח (או 180 ש”ח לבוגרים) – מ”ל אחד לטיפול = בקבוקון אחד לכל הסדרה</a:t>
-            </a:r>
-            <a:endParaRPr lang="he-IL" sz="1400" dirty="0"/>
-          </a:p>
-          <a:p>
-            <a:pPr rtl="1" algn="r" indent="0" marL="0">
-              <a:lnSpc>
-                <a:spcPct val="112000"/>
-              </a:lnSpc>
-              <a:spcAft>
-                <a:spcPts val="500"/>
-              </a:spcAft>
-              <a:buNone/>
-            </a:pPr>
-            <a:r>
-              <a:rPr lang="he-IL" altLang="en-US" sz="1400" dirty="0">
-                <a:solidFill>
-                  <a:srgbClr val="26221E"/>
-                </a:solidFill>
-                <a:latin typeface="Arial" pitchFamily="34" charset="0"/>
-                <a:ea typeface="Arial" pitchFamily="34" charset="-122"/>
-                <a:cs typeface="Arial" pitchFamily="34" charset="-120"/>
-              </a:rPr>
-              <a:t>ציוד מתכלה: 3 × 50 = 150 ש”ח</a:t>
-            </a:r>
-            <a:endParaRPr lang="he-IL" sz="1400" dirty="0"/>
-          </a:p>
-          <a:p>
-            <a:pPr rtl="1" algn="r" indent="0" marL="0">
-              <a:lnSpc>
-                <a:spcPct val="112000"/>
+                <a:spcPct val="110000"/>
               </a:lnSpc>
               <a:buNone/>
             </a:pPr>
@@ -14728,7 +14864,7 @@
                 <a:ea typeface="Arial" pitchFamily="34" charset="-122"/>
                 <a:cs typeface="Arial" pitchFamily="34" charset="-120"/>
               </a:rPr>
-              <a:t>סה”כ עלות לסדרה: 400 ש”ח | לבוגרי הקורס: 330 ש”ח</a:t>
+              <a:t>עלות חומרים: 2 מזרקי מילוי 660 + סלבוסטר 1 מ”ל 83 + ציוד מתכלה כ־50 = 793 ש”ח | לבוגרי הקורס: 610 ש”ח</a:t>
             </a:r>
             <a:endParaRPr lang="he-IL" sz="1400" dirty="0"/>
           </a:p>
@@ -14736,18 +14872,18 @@
       </p:sp>
       <p:sp>
         <p:nvSpPr>
-          <p:cNvPr id="8" name="Shape 5"/>
+          <p:cNvPr id="9" name="Shape 6"/>
           <p:cNvSpPr/>
           <p:nvPr/>
         </p:nvSpPr>
         <p:spPr>
           <a:xfrm>
-            <a:off x="548640" y="3291840"/>
-            <a:ext cx="11091672" cy="1097280"/>
+            <a:off x="548640" y="3794760"/>
+            <a:ext cx="11091672" cy="1051560"/>
           </a:xfrm>
           <a:prstGeom prst="roundRect">
             <a:avLst>
-              <a:gd name="adj" fmla="val 8333"/>
+              <a:gd name="adj" fmla="val 8696"/>
             </a:avLst>
           </a:prstGeom>
           <a:solidFill>
@@ -14765,13 +14901,13 @@
       </p:sp>
       <p:sp>
         <p:nvSpPr>
-          <p:cNvPr id="9" name="Text 6"/>
+          <p:cNvPr id="10" name="Text 7"/>
           <p:cNvSpPr/>
           <p:nvPr/>
         </p:nvSpPr>
         <p:spPr>
           <a:xfrm>
-            <a:off x="868680" y="3456432"/>
+            <a:off x="868680" y="3931920"/>
             <a:ext cx="10451592" cy="822960"/>
           </a:xfrm>
           <a:prstGeom prst="rect">
@@ -14794,15 +14930,15 @@
               <a:buNone/>
             </a:pPr>
             <a:r>
-              <a:rPr lang="he-IL" altLang="en-US" sz="1400" b="1" dirty="0">
-                <a:solidFill>
-                  <a:srgbClr val="8A6E52"/>
-                </a:solidFill>
-                <a:latin typeface="Arial" pitchFamily="34" charset="0"/>
-                <a:ea typeface="Arial" pitchFamily="34" charset="-122"/>
-                <a:cs typeface="Arial" pitchFamily="34" charset="-120"/>
-              </a:rPr>
-              <a:t>מחיר למטופלת – לפי המחירון המומלץ</a:t>
+              <a:rPr lang="he-IL" altLang="en-US" sz="1400" dirty="0">
+                <a:solidFill>
+                  <a:srgbClr val="26221E"/>
+                </a:solidFill>
+                <a:latin typeface="Arial" pitchFamily="34" charset="0"/>
+                <a:ea typeface="Arial" pitchFamily="34" charset="-122"/>
+                <a:cs typeface="Arial" pitchFamily="34" charset="-120"/>
+              </a:rPr>
+              <a:t>בנפרד לפי המחירון: שני מזרקים (אזורים כלליים) 2,600 ₪ + סלבוסטר 1,500 ₪ = 4,100 ₪</a:t>
             </a:r>
             <a:endParaRPr lang="he-IL" sz="1400" dirty="0"/>
           </a:p>
@@ -14814,15 +14950,15 @@
               <a:buNone/>
             </a:pPr>
             <a:r>
-              <a:rPr lang="he-IL" altLang="en-US" sz="1700" b="1" dirty="0">
-                <a:solidFill>
-                  <a:srgbClr val="26221E"/>
-                </a:solidFill>
-                <a:latin typeface="Arial" pitchFamily="34" charset="0"/>
-                <a:ea typeface="Arial" pitchFamily="34" charset="-122"/>
-                <a:cs typeface="Arial" pitchFamily="34" charset="-120"/>
-              </a:rPr>
-              <a:t>סדרה של 3 טיפולים: 4,200 ₪ (חיסכון של 300 ₪ למטופלת)</a:t>
+              <a:rPr lang="he-IL" altLang="en-US" sz="1400" b="1" dirty="0">
+                <a:solidFill>
+                  <a:srgbClr val="8A6E52"/>
+                </a:solidFill>
+                <a:latin typeface="Arial" pitchFamily="34" charset="0"/>
+                <a:ea typeface="Arial" pitchFamily="34" charset="-122"/>
+                <a:cs typeface="Arial" pitchFamily="34" charset="-120"/>
+              </a:rPr>
+              <a:t>מחיר מומלץ לתוכנית המשולבת: 3,500 ₪</a:t>
             </a:r>
             <a:endParaRPr lang="he-IL" sz="1400" dirty="0"/>
           </a:p>
@@ -14830,18 +14966,18 @@
       </p:sp>
       <p:sp>
         <p:nvSpPr>
-          <p:cNvPr id="10" name="Shape 7"/>
+          <p:cNvPr id="11" name="Shape 8"/>
           <p:cNvSpPr/>
           <p:nvPr/>
         </p:nvSpPr>
         <p:spPr>
           <a:xfrm>
-            <a:off x="548640" y="4526280"/>
-            <a:ext cx="11091672" cy="1463040"/>
+            <a:off x="548640" y="4983480"/>
+            <a:ext cx="11091672" cy="1051560"/>
           </a:xfrm>
           <a:prstGeom prst="roundRect">
             <a:avLst>
-              <a:gd name="adj" fmla="val 6250"/>
+              <a:gd name="adj" fmla="val 8696"/>
             </a:avLst>
           </a:prstGeom>
           <a:solidFill>
@@ -14859,14 +14995,14 @@
       </p:sp>
       <p:sp>
         <p:nvSpPr>
-          <p:cNvPr id="11" name="Text 8"/>
+          <p:cNvPr id="12" name="Text 9"/>
           <p:cNvSpPr/>
           <p:nvPr/>
         </p:nvSpPr>
         <p:spPr>
           <a:xfrm>
-            <a:off x="868680" y="4727448"/>
-            <a:ext cx="10451592" cy="1097280"/>
+            <a:off x="868680" y="5120640"/>
+            <a:ext cx="10451592" cy="822960"/>
           </a:xfrm>
           <a:prstGeom prst="rect">
             <a:avLst/>
@@ -14880,15 +15016,15 @@
           <a:p>
             <a:pPr rtl="1" algn="r" indent="0" marL="0">
               <a:lnSpc>
-                <a:spcPct val="115000"/>
+                <a:spcPct val="112000"/>
               </a:lnSpc>
               <a:spcAft>
-                <a:spcPts val="600"/>
+                <a:spcPts val="500"/>
               </a:spcAft>
               <a:buNone/>
             </a:pPr>
             <a:r>
-              <a:rPr lang="he-IL" altLang="en-US" sz="1450" b="1" dirty="0">
+              <a:rPr lang="he-IL" altLang="en-US" sz="1350" b="1" dirty="0">
                 <a:solidFill>
                   <a:srgbClr val="FFFFFF"/>
                 </a:solidFill>
@@ -14896,19 +15032,19 @@
                 <a:ea typeface="Arial" pitchFamily="34" charset="-122"/>
                 <a:cs typeface="Arial" pitchFamily="34" charset="-120"/>
               </a:rPr>
-              <a:t>רווח רגיל: 3,800 ש”ח (90.5%) | רווח לבוגר קורס: 3,870 ש”ח (92.1%)</a:t>
-            </a:r>
-            <a:endParaRPr lang="he-IL" sz="1450" dirty="0"/>
+              <a:t>רווח רגיל: 2,707 ש”ח (77.3%) | לבוגר קורס: 2,890 ש”ח (82.6%)</a:t>
+            </a:r>
+            <a:endParaRPr lang="he-IL" sz="1350" dirty="0"/>
           </a:p>
           <a:p>
             <a:pPr rtl="1" algn="r" indent="0" marL="0">
               <a:lnSpc>
-                <a:spcPct val="115000"/>
+                <a:spcPct val="112000"/>
               </a:lnSpc>
               <a:buNone/>
             </a:pPr>
             <a:r>
-              <a:rPr lang="he-IL" altLang="en-US" sz="1450" dirty="0">
+              <a:rPr lang="he-IL" altLang="en-US" sz="1350" dirty="0">
                 <a:solidFill>
                   <a:srgbClr val="A3866A"/>
                 </a:solidFill>
@@ -14916,9 +15052,9 @@
                 <a:ea typeface="Arial" pitchFamily="34" charset="-122"/>
                 <a:cs typeface="Arial" pitchFamily="34" charset="-120"/>
               </a:rPr>
-              <a:t>סדרה = המטופלת מתחייבת להמשך, אתם ממקסמים כל בקבוקון – וההמשכיות הטיפולית מובנית מראש.</a:t>
-            </a:r>
-            <a:endParaRPr lang="he-IL" sz="1450" dirty="0"/>
+              <a:t>טיפלתם במקור ולא בסימפטום – תוצאה טובה יותר, ועסקה גדולה פי 2.5 ממזרק בודד.</a:t>
+            </a:r>
+            <a:endParaRPr lang="he-IL" sz="1350" dirty="0"/>
           </a:p>
         </p:txBody>
       </p:sp>

</xml_diff>

<commit_message>
media-memory: slide 29 rebuilt as multi-modality lower-third plan (volume + botox DAO + skin quality)
Co-Authored-By: Claude Fable 5 <noreply@anthropic.com>
Claude-Session: https://claude.ai/code/session_012oaUYezjbRZg4R6ujPtnYc
</commit_message>
<xml_diff>
--- a/media-memory/2026/08/11bf5ee6-c7c9-42de-98d1-555909805943_BEYOND-THE-PRACTICE-full-refreshed.pptx
+++ b/media-memory/2026/08/11bf5ee6-c7c9-42de-98d1-555909805943_BEYOND-THE-PRACTICE-full-refreshed.pptx
@@ -14656,7 +14656,7 @@
                 <a:ea typeface="Arial" pitchFamily="34" charset="-122"/>
                 <a:cs typeface="Arial" pitchFamily="34" charset="-120"/>
               </a:rPr>
-              <a:t>תוכנית משולבת נוספת: קמטי נאזולביאל ונפח הפנים</a:t>
+              <a:t>תוכנית משולבת נוספת: הרמוניה של השליש התחתון</a:t>
             </a:r>
             <a:endParaRPr lang="he-IL" sz="2300" dirty="0"/>
           </a:p>
@@ -14724,7 +14724,7 @@
                 <a:ea typeface="Arial" pitchFamily="34" charset="-122"/>
                 <a:cs typeface="Arial" pitchFamily="34" charset="-120"/>
               </a:rPr>
-              <a:t>אבל הקמט הוא הסימפטום – המקור הוא איבוד נפח בעצמות הלחיים:</a:t>
+              <a:t>אבל הקמט הוא הסימפטום – בשליש התחתון בונים מענה שלם, לא רק ממלאים קו:</a:t>
             </a:r>
             <a:endParaRPr lang="he-IL" sz="1350" dirty="0"/>
           </a:p>
@@ -14748,7 +14748,7 @@
                 <a:ea typeface="Arial" pitchFamily="34" charset="-122"/>
                 <a:cs typeface="Arial" pitchFamily="34" charset="-120"/>
               </a:rPr>
-              <a:t>שחזור נפח בעצמות הלחיים – טיפול במקור הנפילה (מזרק חומצה היאלורונית)</a:t>
+              <a:t>שחזור נפח בעצמות הלחיים – מילוי שמטפל במקור הנפילה (מזרק חומצה היאלורונית)</a:t>
             </a:r>
             <a:endParaRPr lang="he-IL" sz="1350" dirty="0"/>
           </a:p>
@@ -14772,7 +14772,7 @@
                 <a:ea typeface="Arial" pitchFamily="34" charset="-122"/>
                 <a:cs typeface="Arial" pitchFamily="34" charset="-120"/>
               </a:rPr>
-              <a:t>השלמת מילוי עדינה בקמט עצמו, במידת הצורך (מזרק שני)</a:t>
+              <a:t>בוטוקס לשריר ה-DAO – לשחרור המשיכה של זוויות הפה כלפי מטה, וליצירת אפקט הרמה טבעי</a:t>
             </a:r>
             <a:endParaRPr lang="he-IL" sz="1350" dirty="0"/>
           </a:p>
@@ -14793,7 +14793,7 @@
                 <a:ea typeface="Arial" pitchFamily="34" charset="-122"/>
                 <a:cs typeface="Arial" pitchFamily="34" charset="-120"/>
               </a:rPr>
-              <a:t>סלבוסטר – שיפור מרקם, לחות ואלסטיות של העור באזור (1 מ”ל)</a:t>
+              <a:t>סלבוסטר – שיפור מרקם העור, לחות וטיפול בקמטוטים עדינים סביב הפה (1 מ”ל)</a:t>
             </a:r>
             <a:endParaRPr lang="he-IL" sz="1350" dirty="0"/>
           </a:p>
@@ -14808,11 +14808,11 @@
         <p:spPr>
           <a:xfrm>
             <a:off x="548640" y="2788920"/>
-            <a:ext cx="11091672" cy="868680"/>
+            <a:ext cx="11091672" cy="960120"/>
           </a:xfrm>
           <a:prstGeom prst="roundRect">
             <a:avLst>
-              <a:gd name="adj" fmla="val 10526"/>
+              <a:gd name="adj" fmla="val 9524"/>
             </a:avLst>
           </a:prstGeom>
           <a:solidFill>
@@ -14836,8 +14836,8 @@
         </p:nvSpPr>
         <p:spPr>
           <a:xfrm>
-            <a:off x="868680" y="2788920"/>
-            <a:ext cx="10451592" cy="868680"/>
+            <a:off x="868680" y="2898648"/>
+            <a:ext cx="10451592" cy="777240"/>
           </a:xfrm>
           <a:prstGeom prst="rect">
             <a:avLst/>
@@ -14846,8 +14846,31 @@
           <a:ln/>
         </p:spPr>
         <p:txBody>
-          <a:bodyPr wrap="square" lIns="0" tIns="0" rIns="0" bIns="0" rtlCol="0" anchor="ctr"/>
+          <a:bodyPr wrap="square" lIns="0" tIns="0" rIns="0" bIns="0" rtlCol="0" anchor="t"/>
           <a:lstStyle/>
+          <a:p>
+            <a:pPr rtl="1" algn="r" indent="0" marL="0">
+              <a:lnSpc>
+                <a:spcPct val="110000"/>
+              </a:lnSpc>
+              <a:spcAft>
+                <a:spcPts val="400"/>
+              </a:spcAft>
+              <a:buNone/>
+            </a:pPr>
+            <a:r>
+              <a:rPr lang="he-IL" altLang="en-US" sz="1350" b="1" dirty="0">
+                <a:solidFill>
+                  <a:srgbClr val="26221E"/>
+                </a:solidFill>
+                <a:latin typeface="Arial" pitchFamily="34" charset="0"/>
+                <a:ea typeface="Arial" pitchFamily="34" charset="-122"/>
+                <a:cs typeface="Arial" pitchFamily="34" charset="-120"/>
+              </a:rPr>
+              <a:t>עלות חומרים (בשיטת החישוב של דוגמת שקעי העיניים): מזרק מילוי 330 + סלבוסטר 1 מ”ל 83 + ציוד מתכלה כ־50 = 463 ש”ח | לבוגרי הקורס: 360 ש”ח</a:t>
+            </a:r>
+            <a:endParaRPr lang="he-IL" sz="1350" dirty="0"/>
+          </a:p>
           <a:p>
             <a:pPr rtl="1" algn="r" indent="0" marL="0">
               <a:lnSpc>
@@ -14856,17 +14879,17 @@
               <a:buNone/>
             </a:pPr>
             <a:r>
-              <a:rPr lang="he-IL" altLang="en-US" sz="1400" b="1" dirty="0">
-                <a:solidFill>
-                  <a:srgbClr val="26221E"/>
-                </a:solidFill>
-                <a:latin typeface="Arial" pitchFamily="34" charset="0"/>
-                <a:ea typeface="Arial" pitchFamily="34" charset="-122"/>
-                <a:cs typeface="Arial" pitchFamily="34" charset="-120"/>
-              </a:rPr>
-              <a:t>עלות חומרים: 2 מזרקי מילוי 660 + סלבוסטר 1 מ”ל 83 + ציוד מתכלה כ־50 = 793 ש”ח | לבוגרי הקורס: 610 ש”ח</a:t>
-            </a:r>
-            <a:endParaRPr lang="he-IL" sz="1400" dirty="0"/>
+              <a:rPr lang="he-IL" altLang="en-US" sz="1200" dirty="0">
+                <a:solidFill>
+                  <a:srgbClr val="6E655B"/>
+                </a:solidFill>
+                <a:latin typeface="Arial" pitchFamily="34" charset="0"/>
+                <a:ea typeface="Arial" pitchFamily="34" charset="-122"/>
+                <a:cs typeface="Arial" pitchFamily="34" charset="-120"/>
+              </a:rPr>
+              <a:t>בתוספת יחידות הבוטוקס לפי השימוש בפועל</a:t>
+            </a:r>
+            <a:endParaRPr lang="he-IL" sz="1350" dirty="0"/>
           </a:p>
         </p:txBody>
       </p:sp>
@@ -14878,12 +14901,12 @@
         </p:nvSpPr>
         <p:spPr>
           <a:xfrm>
-            <a:off x="548640" y="3794760"/>
-            <a:ext cx="11091672" cy="1051560"/>
+            <a:off x="548640" y="3886200"/>
+            <a:ext cx="11091672" cy="1005840"/>
           </a:xfrm>
           <a:prstGeom prst="roundRect">
             <a:avLst>
-              <a:gd name="adj" fmla="val 8696"/>
+              <a:gd name="adj" fmla="val 9091"/>
             </a:avLst>
           </a:prstGeom>
           <a:solidFill>
@@ -14907,8 +14930,8 @@
         </p:nvSpPr>
         <p:spPr>
           <a:xfrm>
-            <a:off x="868680" y="3931920"/>
-            <a:ext cx="10451592" cy="822960"/>
+            <a:off x="868680" y="4023360"/>
+            <a:ext cx="10451592" cy="777240"/>
           </a:xfrm>
           <a:prstGeom prst="rect">
             <a:avLst/>
@@ -14938,7 +14961,7 @@
                 <a:ea typeface="Arial" pitchFamily="34" charset="-122"/>
                 <a:cs typeface="Arial" pitchFamily="34" charset="-120"/>
               </a:rPr>
-              <a:t>בנפרד לפי המחירון: שני מזרקים (אזורים כלליים) 2,600 ₪ + סלבוסטר 1,500 ₪ = 4,100 ₪</a:t>
+              <a:t>בנפרד לפי המחירון: מזרק (אזור כללי) 1,400 ₪ + בוטוקס אזור אחד 500 ₪ + סלבוסטר 1,500 ₪ = 3,400 ₪</a:t>
             </a:r>
             <a:endParaRPr lang="he-IL" sz="1400" dirty="0"/>
           </a:p>
@@ -14958,7 +14981,7 @@
                 <a:ea typeface="Arial" pitchFamily="34" charset="-122"/>
                 <a:cs typeface="Arial" pitchFamily="34" charset="-120"/>
               </a:rPr>
-              <a:t>מחיר מומלץ לתוכנית המשולבת: 3,500 ₪</a:t>
+              <a:t>מחיר מומלץ לתוכנית המשולבת: 2,800 ₪</a:t>
             </a:r>
             <a:endParaRPr lang="he-IL" sz="1400" dirty="0"/>
           </a:p>
@@ -14972,12 +14995,12 @@
         </p:nvSpPr>
         <p:spPr>
           <a:xfrm>
-            <a:off x="548640" y="4983480"/>
-            <a:ext cx="11091672" cy="1051560"/>
+            <a:off x="548640" y="5029200"/>
+            <a:ext cx="11091672" cy="1005840"/>
           </a:xfrm>
           <a:prstGeom prst="roundRect">
             <a:avLst>
-              <a:gd name="adj" fmla="val 8696"/>
+              <a:gd name="adj" fmla="val 9091"/>
             </a:avLst>
           </a:prstGeom>
           <a:solidFill>
@@ -15001,8 +15024,8 @@
         </p:nvSpPr>
         <p:spPr>
           <a:xfrm>
-            <a:off x="868680" y="5120640"/>
-            <a:ext cx="10451592" cy="822960"/>
+            <a:off x="868680" y="5166360"/>
+            <a:ext cx="10451592" cy="777240"/>
           </a:xfrm>
           <a:prstGeom prst="rect">
             <a:avLst/>
@@ -15032,7 +15055,7 @@
                 <a:ea typeface="Arial" pitchFamily="34" charset="-122"/>
                 <a:cs typeface="Arial" pitchFamily="34" charset="-120"/>
               </a:rPr>
-              <a:t>רווח רגיל: 2,707 ש”ח (77.3%) | לבוגר קורס: 2,890 ש”ח (82.6%)</a:t>
+              <a:t>רווח רגיל: 2,337 ש”ח (83.5%) | לבוגר קורס: 2,440 ש”ח (87.1%)</a:t>
             </a:r>
             <a:endParaRPr lang="he-IL" sz="1350" dirty="0"/>
           </a:p>
@@ -15052,7 +15075,7 @@
                 <a:ea typeface="Arial" pitchFamily="34" charset="-122"/>
                 <a:cs typeface="Arial" pitchFamily="34" charset="-120"/>
               </a:rPr>
-              <a:t>טיפלתם במקור ולא בסימפטום – תוצאה טובה יותר, ועסקה גדולה פי 2.5 ממזרק בודד.</a:t>
+              <a:t>שלוש מודליות – נפח, שריר ואיכות עור – במקום קו אחד מלא. תוצאה הרמונית, ועסקה כפולה ממזרק בודד.</a:t>
             </a:r>
             <a:endParaRPr lang="he-IL" sz="1350" dirty="0"/>
           </a:p>

</xml_diff>

<commit_message>
media-memory: lower-third plan corrected to minimum 3 filler syringes, pricing recalculated
Co-Authored-By: Claude Fable 5 <noreply@anthropic.com>
Claude-Session: https://claude.ai/code/session_012oaUYezjbRZg4R6ujPtnYc
</commit_message>
<xml_diff>
--- a/media-memory/2026/08/11bf5ee6-c7c9-42de-98d1-555909805943_BEYOND-THE-PRACTICE-full-refreshed.pptx
+++ b/media-memory/2026/08/11bf5ee6-c7c9-42de-98d1-555909805943_BEYOND-THE-PRACTICE-full-refreshed.pptx
@@ -14748,7 +14748,7 @@
                 <a:ea typeface="Arial" pitchFamily="34" charset="-122"/>
                 <a:cs typeface="Arial" pitchFamily="34" charset="-120"/>
               </a:rPr>
-              <a:t>שחזור נפח בעצמות הלחיים – מילוי שמטפל במקור הנפילה (מזרק חומצה היאלורונית)</a:t>
+              <a:t>שחזור נפח בעצמות הלחיים ותמיכה במבנה – בשליש התחתון מדובר במינימום 3 מזרקי חומצה היאלורונית</a:t>
             </a:r>
             <a:endParaRPr lang="he-IL" sz="1350" dirty="0"/>
           </a:p>
@@ -14867,7 +14867,7 @@
                 <a:ea typeface="Arial" pitchFamily="34" charset="-122"/>
                 <a:cs typeface="Arial" pitchFamily="34" charset="-120"/>
               </a:rPr>
-              <a:t>עלות חומרים (בשיטת החישוב של דוגמת שקעי העיניים): מזרק מילוי 330 + סלבוסטר 1 מ”ל 83 + ציוד מתכלה כ־50 = 463 ש”ח | לבוגרי הקורס: 360 ש”ח</a:t>
+              <a:t>עלות חומרים: 3 מזרקי מילוי 990 + סלבוסטר 1 מ”ל 83 + ציוד מתכלה כ־50 = 1,123 ש”ח | לבוגרי הקורס: 860 ש”ח</a:t>
             </a:r>
             <a:endParaRPr lang="he-IL" sz="1350" dirty="0"/>
           </a:p>
@@ -14961,7 +14961,7 @@
                 <a:ea typeface="Arial" pitchFamily="34" charset="-122"/>
                 <a:cs typeface="Arial" pitchFamily="34" charset="-120"/>
               </a:rPr>
-              <a:t>בנפרד לפי המחירון: מזרק (אזור כללי) 1,400 ₪ + בוטוקס אזור אחד 500 ₪ + סלבוסטר 1,500 ₪ = 3,400 ₪</a:t>
+              <a:t>בנפרד לפי המחירון: 3 מזרקים (אזורים כלליים) 4,000 ₪ + בוטוקס אזור אחד 500 ₪ + סלבוסטר 1,500 ₪ = 6,000 ₪</a:t>
             </a:r>
             <a:endParaRPr lang="he-IL" sz="1400" dirty="0"/>
           </a:p>
@@ -14981,7 +14981,7 @@
                 <a:ea typeface="Arial" pitchFamily="34" charset="-122"/>
                 <a:cs typeface="Arial" pitchFamily="34" charset="-120"/>
               </a:rPr>
-              <a:t>מחיר מומלץ לתוכנית המשולבת: 2,800 ₪</a:t>
+              <a:t>מחיר מומלץ לתוכנית המשולבת: 5,000 ₪ (בקו אחד עם מדיניות החבילות – מעל 5,000 ₪: 15% הנחה)</a:t>
             </a:r>
             <a:endParaRPr lang="he-IL" sz="1400" dirty="0"/>
           </a:p>
@@ -15055,7 +15055,7 @@
                 <a:ea typeface="Arial" pitchFamily="34" charset="-122"/>
                 <a:cs typeface="Arial" pitchFamily="34" charset="-120"/>
               </a:rPr>
-              <a:t>רווח רגיל: 2,337 ש”ח (83.5%) | לבוגר קורס: 2,440 ש”ח (87.1%)</a:t>
+              <a:t>רווח רגיל: 3,877 ש”ח (77.5%) | לבוגר קורס: 4,140 ש”ח (82.8%)</a:t>
             </a:r>
             <a:endParaRPr lang="he-IL" sz="1350" dirty="0"/>
           </a:p>
@@ -15075,7 +15075,7 @@
                 <a:ea typeface="Arial" pitchFamily="34" charset="-122"/>
                 <a:cs typeface="Arial" pitchFamily="34" charset="-120"/>
               </a:rPr>
-              <a:t>שלוש מודליות – נפח, שריר ואיכות עור – במקום קו אחד מלא. תוצאה הרמונית, ועסקה כפולה ממזרק בודד.</a:t>
+              <a:t>שלוש מודליות – נפח, שריר ואיכות עור – במקום קו אחד מלא. תוצאה הרמונית, ועסקה של 5,000 ₪ במקום 1,400 ₪.</a:t>
             </a:r>
             <a:endParaRPr lang="he-IL" sz="1350" dirty="0"/>
           </a:p>

</xml_diff>